<commit_message>
Recale les aides et le ROI sur des valeurs realistes (alignees sur projets comparables)
- Aides plus prudentes : ~20 000 EUR (Sc.1) / ~30 000 EUR (Sc.2)
- Reste a charge : 22 500 EUR (Sc.1) / 33 000 EUR (Sc.2)
- ROI base sur la facture reelle (~3 800 EUR/an) : ~14-15 ans
- Cout global 30 ans avec hausse energie +5 %/an : 252k / 188,5k / 169k
- Synthese et conclusion mises a jour en coherence

https://claude.ai/code/session_01R4E5satKyZK8NHDSVCDJDk
</commit_message>
<xml_diff>
--- a/Soutenance_Renovation_Saint-Jean-de-Chevelu.pptx
+++ b/Soutenance_Renovation_Saint-Jean-de-Chevelu.pptx
@@ -547,7 +547,7 @@
               <a:defRPr sz="1200"/>
             </a:pPr>
             <a:r>
-              <a:t>Cout global sur 30 ans (travaux + energie)</a:t>
+              <a:t>Cout global 30 ans (travaux + energie, +5 %/an)</a:t>
             </a:r>
           </a:p>
         </c:rich>
@@ -622,13 +622,13 @@
                 <c:formatCode>General</c:formatCode>
                 <c:ptCount val="3"/>
                 <c:pt idx="0">
-                  <c:v>250650</c:v>
+                  <c:v>252000</c:v>
                 </c:pt>
                 <c:pt idx="1">
-                  <c:v>177500</c:v>
+                  <c:v>188500</c:v>
                 </c:pt>
                 <c:pt idx="2">
-                  <c:v>153000</c:v>
+                  <c:v>169000</c:v>
                 </c:pt>
               </c:numCache>
             </c:numRef>
@@ -1799,7 +1799,7 @@
           <a:lstStyle/>
           <a:p>
             <a:r>
-              <a:t>Le financement, calcule pour ce foyer modeste de 4 personnes a 40 000 euros par an. Les travaux sont une renovation d'ampleur, eligible a MaPrimeRenov' parcours accompagne, avec des taux eleves pour les revenus modestes : 65 % pour un gain de 3 classes au scenario 1, 70 % pour 5 classes au scenario 2. Avec les CEE, le reste a charge tombe a 14 000 euros pour le scenario 1 et 17 500 pour le scenario 2. On deduit l'apport de 10 000 euros : il ne reste que 4 000 a 7 500 euros, finances par un eco-PTZ a taux zero. Le projet reste donc tout a fait dans le budget de la famille - et l'eco-PTZ se rembourse pour environ 40 euros par mois, tres inferieurs aux economies d'energie.</a:t>
+              <a:t>Le financement, avec une estimation PRUDENTE des aides - plus realiste que les taux maximaux. Pour ce foyer de 4 personnes, MaPrimeRenov' et les CEE couvrent environ 20 000 euros au scenario 1 et 30 000 euros au scenario 2. Le reste a charge s'eleve donc a 22 500 euros pour le scenario 1 et 33 000 euros pour le scenario 2 - des montants coherents avec ce qu'observent des projets comparables. On deduit l'apport de 10 000 euros, et le solde - 12 500 a 23 000 euros - est finance par un eco-PTZ a taux zero. Le projet reste dans le budget : la mensualite de l'eco-PTZ est largement couverte par les economies d'energie.</a:t>
             </a:r>
           </a:p>
         </p:txBody>
@@ -1939,7 +1939,7 @@
           <a:lstStyle/>
           <a:p>
             <a:r>
-              <a:t>L'analyse en cout global tranche. Sur 30 ans, sans rien faire on depense 250 000 euros ; le scenario 1 ramene a 177 500, le scenario 2 a 153 000 - travaux compris. Malgre un investissement initial plus eleve, le scenario 2 reste le moins cher au final. Les couts mensuels d'energie passent de 696 a 250 euros. Et grace aux aides elevees, l'amortissement sur le reste a charge est tres rapide : environ 3,6 ans pour le scenario 1 et 3,3 ans pour le scenario 2. Si le jury m'interroge : j'ai retenu 30 ans ; en integrant la hausse du prix de l'energie, l'ecart se creuserait encore en faveur du scenario 2.</a:t>
+              <a:t>L'analyse economique se base sur la facture REELLE du foyer - environ 3 800 euros par an - et non sur le cout conventionnel du DPE, qui le surestime. Apres travaux, la facture tombe a 2 200 euros au scenario 1 et 1 600 euros au scenario 2, soit des economies de 1 600 a 2 200 euros par an. Sur le reste a charge, le retour sur investissement est d'environ 14 ans pour le scenario 1 et 15 ans pour le scenario 2 - coherent avec des projets comparables. Pour le cout global, j'integre une hausse du prix de l'energie de 5 % par an, comme attendu : sur 30 ans, ne rien faire coute 252 000 euros, le scenario 1 188 500, et le scenario 2 169 000. Malgre un investissement plus eleve, le scenario 2 reste le plus avantageux sur la duree.</a:t>
             </a:r>
           </a:p>
         </p:txBody>
@@ -2079,7 +2079,7 @@
           <a:lstStyle/>
           <a:p>
             <a:r>
-              <a:t>Pour conclure : au regard de la performance, de la sortie du fioul, de la rentabilite et du respect du bati, je recommande le scenario 2, qui fait passer le logement de G a B et reste le moins cher sur 30 ans, tout en restant dans le budget grace aux aides et a l'apport. Si le budget initial est un frein, le scenario 1 par etapes est une excellente premiere etape, completee plus tard par le chauffage. J'ai aussi remis au maitre d'ouvrage des conseils de sobriete simples qui amplifient les economies. Je vous remercie et je suis pret pour vos questions.</a:t>
+              <a:t>Pour conclure : au regard de la performance, de la sortie du fioul, de la rentabilite et du respect du bati, je recommande le scenario 2, qui fait passer le logement de G a B et reste le moins cher sur 30 ans (avec hausse de l'energie), tout en restant dans le budget grace aux aides et a l'apport. Si le budget initial est un frein, le scenario 1 par etapes est une excellente premiere etape, completee plus tard par le chauffage. J'ai aussi remis au maitre d'ouvrage des conseils de sobriete simples qui amplifient les economies. Je vous remercie et je suis pret pour vos questions.</a:t>
             </a:r>
           </a:p>
         </p:txBody>
@@ -21529,7 +21529,7 @@
         </p:nvGraphicFramePr>
         <p:xfrm>
           <a:off x="822960" y="1691640"/>
-          <a:ext cx="10515600" cy="3328416"/>
+          <a:ext cx="10515600" cy="3364992"/>
         </p:xfrm>
         <a:graphic>
           <a:graphicData uri="http://schemas.openxmlformats.org/drawingml/2006/table">
@@ -21542,7 +21542,7 @@
                 <a:gridCol w="2834640"/>
                 <a:gridCol w="2834640"/>
               </a:tblGrid>
-              <a:tr h="475488">
+              <a:tr h="420624">
                 <a:tc>
                   <a:txBody>
                     <a:bodyPr wrap="square"/>
@@ -21613,7 +21613,7 @@
                   </a:tcPr>
                 </a:tc>
               </a:tr>
-              <a:tr h="475488">
+              <a:tr h="420624">
                 <a:tc>
                   <a:txBody>
                     <a:bodyPr wrap="square"/>
@@ -21684,7 +21684,7 @@
                   </a:tcPr>
                 </a:tc>
               </a:tr>
-              <a:tr h="475488">
+              <a:tr h="420624">
                 <a:tc>
                   <a:txBody>
                     <a:bodyPr wrap="square"/>
@@ -21698,7 +21698,7 @@
                           </a:solidFill>
                           <a:latin typeface="Calibri"/>
                         </a:rPr>
-                        <a:t>MaPrimeRenov' (parcours accompagne)</a:t>
+                        <a:t>MaPrimeRenov' (estimation prudente)</a:t>
                       </a:r>
                     </a:p>
                   </a:txBody>
@@ -21721,7 +21721,7 @@
                           </a:solidFill>
                           <a:latin typeface="Calibri"/>
                         </a:rPr>
-                        <a:t>- 26 000 €</a:t>
+                        <a:t>- 15 000 €</a:t>
                       </a:r>
                     </a:p>
                   </a:txBody>
@@ -21744,7 +21744,7 @@
                           </a:solidFill>
                           <a:latin typeface="Calibri"/>
                         </a:rPr>
-                        <a:t>- 42 000 €</a:t>
+                        <a:t>- 24 000 €</a:t>
                       </a:r>
                     </a:p>
                   </a:txBody>
@@ -21755,7 +21755,7 @@
                   </a:tcPr>
                 </a:tc>
               </a:tr>
-              <a:tr h="475488">
+              <a:tr h="420624">
                 <a:tc>
                   <a:txBody>
                     <a:bodyPr wrap="square"/>
@@ -21815,7 +21815,7 @@
                           </a:solidFill>
                           <a:latin typeface="Calibri"/>
                         </a:rPr>
-                        <a:t>- 3 500 €</a:t>
+                        <a:t>- 4 000 €</a:t>
                       </a:r>
                     </a:p>
                   </a:txBody>
@@ -21826,7 +21826,78 @@
                   </a:tcPr>
                 </a:tc>
               </a:tr>
-              <a:tr h="475488">
+              <a:tr h="420624">
+                <a:tc>
+                  <a:txBody>
+                    <a:bodyPr wrap="square"/>
+                    <a:lstStyle/>
+                    <a:p>
+                      <a:pPr algn="l"/>
+                      <a:r>
+                        <a:rPr sz="1200" b="1">
+                          <a:solidFill>
+                            <a:srgbClr val="37474F"/>
+                          </a:solidFill>
+                          <a:latin typeface="Calibri"/>
+                        </a:rPr>
+                        <a:t>Aides locales eventuelles</a:t>
+                      </a:r>
+                    </a:p>
+                  </a:txBody>
+                  <a:tcPr marL="76200" marR="76200" marT="12700" marB="12700" anchor="ctr">
+                    <a:solidFill>
+                      <a:srgbClr val="E8F5E9"/>
+                    </a:solidFill>
+                  </a:tcPr>
+                </a:tc>
+                <a:tc>
+                  <a:txBody>
+                    <a:bodyPr wrap="square"/>
+                    <a:lstStyle/>
+                    <a:p>
+                      <a:pPr algn="ctr"/>
+                      <a:r>
+                        <a:rPr sz="1200" b="0">
+                          <a:solidFill>
+                            <a:srgbClr val="37474F"/>
+                          </a:solidFill>
+                          <a:latin typeface="Calibri"/>
+                        </a:rPr>
+                        <a:t>- 2 500 €</a:t>
+                      </a:r>
+                    </a:p>
+                  </a:txBody>
+                  <a:tcPr marL="76200" marR="76200" marT="12700" marB="12700" anchor="ctr">
+                    <a:solidFill>
+                      <a:srgbClr val="E8F5E9"/>
+                    </a:solidFill>
+                  </a:tcPr>
+                </a:tc>
+                <a:tc>
+                  <a:txBody>
+                    <a:bodyPr wrap="square"/>
+                    <a:lstStyle/>
+                    <a:p>
+                      <a:pPr algn="ctr"/>
+                      <a:r>
+                        <a:rPr sz="1200" b="0">
+                          <a:solidFill>
+                            <a:srgbClr val="37474F"/>
+                          </a:solidFill>
+                          <a:latin typeface="Calibri"/>
+                        </a:rPr>
+                        <a:t>- 2 000 €</a:t>
+                      </a:r>
+                    </a:p>
+                  </a:txBody>
+                  <a:tcPr marL="76200" marR="76200" marT="12700" marB="12700" anchor="ctr">
+                    <a:solidFill>
+                      <a:srgbClr val="E8F5E9"/>
+                    </a:solidFill>
+                  </a:tcPr>
+                </a:tc>
+              </a:tr>
+              <a:tr h="420624">
                 <a:tc>
                   <a:txBody>
                     <a:bodyPr wrap="square"/>
@@ -21863,7 +21934,7 @@
                           </a:solidFill>
                           <a:latin typeface="Calibri"/>
                         </a:rPr>
-                        <a:t>14 000 €</a:t>
+                        <a:t>22 500 €</a:t>
                       </a:r>
                     </a:p>
                   </a:txBody>
@@ -21886,7 +21957,7 @@
                           </a:solidFill>
                           <a:latin typeface="Calibri"/>
                         </a:rPr>
-                        <a:t>17 500 €</a:t>
+                        <a:t>33 000 €</a:t>
                       </a:r>
                     </a:p>
                   </a:txBody>
@@ -21897,7 +21968,7 @@
                   </a:tcPr>
                 </a:tc>
               </a:tr>
-              <a:tr h="475488">
+              <a:tr h="420624">
                 <a:tc>
                   <a:txBody>
                     <a:bodyPr wrap="square"/>
@@ -21917,7 +21988,7 @@
                   </a:txBody>
                   <a:tcPr marL="76200" marR="76200" marT="12700" marB="12700" anchor="ctr">
                     <a:solidFill>
-                      <a:srgbClr val="FFFFFF"/>
+                      <a:srgbClr val="E8F5E9"/>
                     </a:solidFill>
                   </a:tcPr>
                 </a:tc>
@@ -21940,7 +22011,7 @@
                   </a:txBody>
                   <a:tcPr marL="76200" marR="76200" marT="12700" marB="12700" anchor="ctr">
                     <a:solidFill>
-                      <a:srgbClr val="FFFFFF"/>
+                      <a:srgbClr val="E8F5E9"/>
                     </a:solidFill>
                   </a:tcPr>
                 </a:tc>
@@ -21963,12 +22034,12 @@
                   </a:txBody>
                   <a:tcPr marL="76200" marR="76200" marT="12700" marB="12700" anchor="ctr">
                     <a:solidFill>
-                      <a:srgbClr val="FFFFFF"/>
+                      <a:srgbClr val="E8F5E9"/>
                     </a:solidFill>
                   </a:tcPr>
                 </a:tc>
               </a:tr>
-              <a:tr h="475488">
+              <a:tr h="420624">
                 <a:tc>
                   <a:txBody>
                     <a:bodyPr wrap="square"/>
@@ -22005,7 +22076,7 @@
                           </a:solidFill>
                           <a:latin typeface="Calibri"/>
                         </a:rPr>
-                        <a:t>4 000 €</a:t>
+                        <a:t>12 500 €</a:t>
                       </a:r>
                     </a:p>
                   </a:txBody>
@@ -22028,7 +22099,7 @@
                           </a:solidFill>
                           <a:latin typeface="Calibri"/>
                         </a:rPr>
-                        <a:t>7 500 €</a:t>
+                        <a:t>23 000 €</a:t>
                       </a:r>
                     </a:p>
                   </a:txBody>
@@ -22051,8 +22122,8 @@
         </p:nvSpPr>
         <p:spPr>
           <a:xfrm>
-            <a:off x="822960" y="5349240"/>
-            <a:ext cx="10515600" cy="914400"/>
+            <a:off x="822960" y="5440680"/>
+            <a:ext cx="10515600" cy="868680"/>
           </a:xfrm>
           <a:prstGeom prst="roundRect">
             <a:avLst/>
@@ -22095,8 +22166,8 @@
         </p:nvSpPr>
         <p:spPr>
           <a:xfrm>
-            <a:off x="1051560" y="5422392"/>
-            <a:ext cx="10058400" cy="777240"/>
+            <a:off x="1051560" y="5504688"/>
+            <a:ext cx="10058400" cy="731520"/>
           </a:xfrm>
           <a:prstGeom prst="rect">
             <a:avLst/>
@@ -22124,7 +22195,7 @@
                 </a:solidFill>
                 <a:latin typeface="Calibri"/>
               </a:rPr>
-              <a:t>Famille modeste (4 pers., ~40 000 €/an) : taux MaPrimeRenov' eleves (65 % a 70 %) pour un gain de 3 a 5 classes. Avec l'apport, le solde (4 000 a 7 500 €) est couvert par un eco-PTZ a 0 % -&gt; projet dans le budget.</a:t>
+              <a:t>Estimation prudente des aides (~20 000 € et ~30 000 €). Apres apport, le solde (12 500 a 23 000 €) est finance par un eco-PTZ a 0 % -&gt; projet dans le budget de la famille.</a:t>
             </a:r>
           </a:p>
         </p:txBody>
@@ -24012,7 +24083,7 @@
                 </a:solidFill>
                 <a:latin typeface="Calibri"/>
               </a:rPr>
-              <a:t>Couts mensuels &amp; ROI</a:t>
+              <a:t>Factures reelles &amp; ROI</a:t>
             </a:r>
           </a:p>
         </p:txBody>
@@ -24148,7 +24219,7 @@
                           </a:solidFill>
                           <a:latin typeface="Calibri"/>
                         </a:rPr>
-                        <a:t>8 355</a:t>
+                        <a:t>3 800</a:t>
                       </a:r>
                     </a:p>
                   </a:txBody>
@@ -24171,7 +24242,7 @@
                           </a:solidFill>
                           <a:latin typeface="Calibri"/>
                         </a:rPr>
-                        <a:t>696</a:t>
+                        <a:t>317</a:t>
                       </a:r>
                     </a:p>
                   </a:txBody>
@@ -24219,7 +24290,7 @@
                           </a:solidFill>
                           <a:latin typeface="Calibri"/>
                         </a:rPr>
-                        <a:t>4 500</a:t>
+                        <a:t>2 200</a:t>
                       </a:r>
                     </a:p>
                   </a:txBody>
@@ -24242,7 +24313,7 @@
                           </a:solidFill>
                           <a:latin typeface="Calibri"/>
                         </a:rPr>
-                        <a:t>375</a:t>
+                        <a:t>183</a:t>
                       </a:r>
                     </a:p>
                   </a:txBody>
@@ -24290,7 +24361,7 @@
                           </a:solidFill>
                           <a:latin typeface="Calibri"/>
                         </a:rPr>
-                        <a:t>3 000</a:t>
+                        <a:t>1 600</a:t>
                       </a:r>
                     </a:p>
                   </a:txBody>
@@ -24313,7 +24384,7 @@
                           </a:solidFill>
                           <a:latin typeface="Calibri"/>
                         </a:rPr>
-                        <a:t>250</a:t>
+                        <a:t>133</a:t>
                       </a:r>
                     </a:p>
                   </a:txBody>
@@ -24459,7 +24530,7 @@
                           </a:solidFill>
                           <a:latin typeface="Calibri"/>
                         </a:rPr>
-                        <a:t>14 000 €</a:t>
+                        <a:t>22 500 €</a:t>
                       </a:r>
                     </a:p>
                   </a:txBody>
@@ -24482,7 +24553,7 @@
                           </a:solidFill>
                           <a:latin typeface="Calibri"/>
                         </a:rPr>
-                        <a:t>17 500 €</a:t>
+                        <a:t>33 000 €</a:t>
                       </a:r>
                     </a:p>
                   </a:txBody>
@@ -24530,7 +24601,7 @@
                           </a:solidFill>
                           <a:latin typeface="Calibri"/>
                         </a:rPr>
-                        <a:t>3 855 €</a:t>
+                        <a:t>1 600 €</a:t>
                       </a:r>
                     </a:p>
                   </a:txBody>
@@ -24553,7 +24624,7 @@
                           </a:solidFill>
                           <a:latin typeface="Calibri"/>
                         </a:rPr>
-                        <a:t>5 355 €</a:t>
+                        <a:t>2 200 €</a:t>
                       </a:r>
                     </a:p>
                   </a:txBody>
@@ -24601,7 +24672,7 @@
                           </a:solidFill>
                           <a:latin typeface="Calibri"/>
                         </a:rPr>
-                        <a:t>~3,6 ans</a:t>
+                        <a:t>~14 ans</a:t>
                       </a:r>
                     </a:p>
                   </a:txBody>
@@ -24624,7 +24695,7 @@
                           </a:solidFill>
                           <a:latin typeface="Calibri"/>
                         </a:rPr>
-                        <a:t>~3,3 ans</a:t>
+                        <a:t>~15 ans</a:t>
                       </a:r>
                     </a:p>
                   </a:txBody>
@@ -25555,7 +25626,7 @@
                           </a:solidFill>
                           <a:latin typeface="Calibri"/>
                         </a:rPr>
-                        <a:t>~28 500 €</a:t>
+                        <a:t>~20 000 €</a:t>
                       </a:r>
                     </a:p>
                   </a:txBody>
@@ -25578,7 +25649,7 @@
                           </a:solidFill>
                           <a:latin typeface="Calibri"/>
                         </a:rPr>
-                        <a:t>~45 500 €</a:t>
+                        <a:t>~30 000 €</a:t>
                       </a:r>
                     </a:p>
                   </a:txBody>
@@ -25649,7 +25720,7 @@
                           </a:solidFill>
                           <a:latin typeface="Calibri"/>
                         </a:rPr>
-                        <a:t>14 000 €</a:t>
+                        <a:t>22 500 €</a:t>
                       </a:r>
                     </a:p>
                   </a:txBody>
@@ -25672,7 +25743,7 @@
                           </a:solidFill>
                           <a:latin typeface="Calibri"/>
                         </a:rPr>
-                        <a:t>17 500 €</a:t>
+                        <a:t>33 000 €</a:t>
                       </a:r>
                     </a:p>
                   </a:txBody>
@@ -25697,7 +25768,7 @@
                           </a:solidFill>
                           <a:latin typeface="Calibri"/>
                         </a:rPr>
-                        <a:t>Cout energie / an</a:t>
+                        <a:t>Cout energie / an (reel)</a:t>
                       </a:r>
                     </a:p>
                   </a:txBody>
@@ -25720,7 +25791,7 @@
                           </a:solidFill>
                           <a:latin typeface="Calibri"/>
                         </a:rPr>
-                        <a:t>8 355 €</a:t>
+                        <a:t>3 800 €</a:t>
                       </a:r>
                     </a:p>
                   </a:txBody>
@@ -25743,7 +25814,7 @@
                           </a:solidFill>
                           <a:latin typeface="Calibri"/>
                         </a:rPr>
-                        <a:t>4 500 €</a:t>
+                        <a:t>2 200 €</a:t>
                       </a:r>
                     </a:p>
                   </a:txBody>
@@ -25766,7 +25837,7 @@
                           </a:solidFill>
                           <a:latin typeface="Calibri"/>
                         </a:rPr>
-                        <a:t>3 000 €</a:t>
+                        <a:t>1 600 €</a:t>
                       </a:r>
                     </a:p>
                   </a:txBody>
@@ -25814,7 +25885,7 @@
                           </a:solidFill>
                           <a:latin typeface="Calibri"/>
                         </a:rPr>
-                        <a:t>250 650 €</a:t>
+                        <a:t>252 000 €</a:t>
                       </a:r>
                     </a:p>
                   </a:txBody>
@@ -25837,7 +25908,7 @@
                           </a:solidFill>
                           <a:latin typeface="Calibri"/>
                         </a:rPr>
-                        <a:t>177 500 €</a:t>
+                        <a:t>188 500 €</a:t>
                       </a:r>
                     </a:p>
                   </a:txBody>
@@ -25860,7 +25931,7 @@
                           </a:solidFill>
                           <a:latin typeface="Calibri"/>
                         </a:rPr>
-                        <a:t>153 000 €</a:t>
+                        <a:t>169 000 €</a:t>
                       </a:r>
                     </a:p>
                   </a:txBody>
@@ -25931,7 +26002,7 @@
                           </a:solidFill>
                           <a:latin typeface="Calibri"/>
                         </a:rPr>
-                        <a:t>~3,6 ans</a:t>
+                        <a:t>~14 ans</a:t>
                       </a:r>
                     </a:p>
                   </a:txBody>
@@ -25954,7 +26025,7 @@
                           </a:solidFill>
                           <a:latin typeface="Calibri"/>
                         </a:rPr>
-                        <a:t>~3,3 ans</a:t>
+                        <a:t>~15 ans</a:t>
                       </a:r>
                     </a:p>
                   </a:txBody>
@@ -26332,7 +26403,7 @@
                 </a:solidFill>
                 <a:latin typeface="Calibri"/>
               </a:rPr>
-              <a:t>cout global le plus bas, ROI ~3,3 ans</a:t>
+              <a:t>cout global le plus bas, ROI ~15 ans</a:t>
             </a:r>
           </a:p>
           <a:p>
@@ -26406,7 +26477,7 @@
                 </a:solidFill>
                 <a:latin typeface="Calibri"/>
               </a:rPr>
-              <a:t>reste a charge 17 500 €, soutenu par aides + apport</a:t>
+              <a:t>reste a charge ~33 000 €, aides ~30 000 € + apport</a:t>
             </a:r>
           </a:p>
         </p:txBody>
@@ -32319,7 +32390,7 @@
                 </a:solidFill>
                 <a:latin typeface="Calibri"/>
               </a:rPr>
-              <a:t>rigueur climatique integree (Savoie, 498 m, zone H1) ; coherence factures / DPE verifiee ; 535 vs ~250 kWhEP/m2.an en moyenne nationale -&gt; plus du double.</a:t>
+              <a:t>rigueur climatique integree (Savoie, 498 m, zone H1) ; facture reelle ~3 800 €/an (chauffage partiel + appoint bois), sous l'estimation conventionnelle du DPE ; 535 vs ~250 kWhEP/m2.an en moyenne nationale.</a:t>
             </a:r>
           </a:p>
         </p:txBody>

</xml_diff>

<commit_message>
Ajoute une diapo annexe References & sources (aides, fournisseurs, donnees techniques)
23e diapositive avec liens cliquables regroupes en 3 categories :
- Aides & financement (France Renov', MaPrimeRenov', Anah, ASDER...)
- Materiaux & equipements (Steico, Ouateco, Aldes, Atlantic, OkoFEN, Hargassner...)
- Donnees & reglementation (ADEME, observatoire DPE, Legifrance, geoportail urbanisme...)

https://claude.ai/code/session_01R4E5satKyZK8NHDSVCDJDk
</commit_message>
<xml_diff>
--- a/Soutenance_Renovation_Saint-Jean-de-Chevelu.pptx
+++ b/Soutenance_Renovation_Saint-Jean-de-Chevelu.pptx
@@ -27,6 +27,7 @@
     <p:sldId id="275" r:id="rId27"/>
     <p:sldId id="276" r:id="rId28"/>
     <p:sldId id="277" r:id="rId29"/>
+    <p:sldId id="278" r:id="rId30"/>
   </p:sldIdLst>
   <p:sldSz cx="12191695" cy="6858000" type="screen4x3"/>
   <p:notesSz cx="6858000" cy="9144000"/>
@@ -2080,6 +2081,76 @@
           <a:p>
             <a:r>
               <a:t>Pour conclure : au regard de la performance, de la sortie du fioul, de la rentabilite et du respect du bati, je recommande le scenario 2, qui fait passer le logement de G a B et reste le moins cher sur 30 ans (avec hausse de l'energie), tout en restant dans le budget grace aux aides et a l'apport. Si le budget initial est un frein, le scenario 1 par etapes est une excellente premiere etape, completee plus tard par le chauffage. J'ai aussi remis au maitre d'ouvrage des conseils de sobriete simples qui amplifient les economies. Je vous remercie et je suis pret pour vos questions.</a:t>
+            </a:r>
+          </a:p>
+        </p:txBody>
+      </p:sp>
+      <p:sp>
+        <p:nvSpPr>
+          <p:cNvPr id="4" name="Slide Number Placeholder 3"/>
+          <p:cNvSpPr>
+            <a:spLocks noGrp="1"/>
+          </p:cNvSpPr>
+          <p:nvPr>
+            <p:ph type="sldNum" idx="5" sz="quarter"/>
+          </p:nvPr>
+        </p:nvSpPr>
+        <p:spPr/>
+      </p:sp>
+    </p:spTree>
+  </p:cSld>
+  <p:clrMapOvr>
+    <a:masterClrMapping/>
+  </p:clrMapOvr>
+</p:notes>
+</file>
+
+<file path=ppt/notesSlides/notesSlide23.xml><?xml version="1.0" encoding="utf-8"?>
+<p:notes xmlns:a="http://schemas.openxmlformats.org/drawingml/2006/main" xmlns:p="http://schemas.openxmlformats.org/presentationml/2006/main" xmlns:r="http://schemas.openxmlformats.org/officeDocument/2006/relationships">
+  <p:cSld>
+    <p:spTree>
+      <p:nvGrpSpPr>
+        <p:cNvPr id="1" name=""/>
+        <p:cNvGrpSpPr/>
+        <p:nvPr/>
+      </p:nvGrpSpPr>
+      <p:grpSpPr>
+        <a:xfrm>
+          <a:off x="0" y="0"/>
+          <a:ext cx="0" cy="0"/>
+          <a:chOff x="0" y="0"/>
+          <a:chExt cx="0" cy="0"/>
+        </a:xfrm>
+      </p:grpSpPr>
+      <p:sp>
+        <p:nvSpPr>
+          <p:cNvPr id="2" name="Slide Image Placeholder 1"/>
+          <p:cNvSpPr>
+            <a:spLocks noGrp="1"/>
+          </p:cNvSpPr>
+          <p:nvPr>
+            <p:ph type="sldImg" idx="2"/>
+          </p:nvPr>
+        </p:nvSpPr>
+        <p:spPr/>
+      </p:sp>
+      <p:sp>
+        <p:nvSpPr>
+          <p:cNvPr id="3" name="Notes Placeholder 2"/>
+          <p:cNvSpPr>
+            <a:spLocks noGrp="1"/>
+          </p:cNvSpPr>
+          <p:nvPr>
+            <p:ph type="body" idx="3" sz="quarter"/>
+          </p:nvPr>
+        </p:nvSpPr>
+        <p:spPr/>
+        <p:txBody>
+          <a:bodyPr/>
+          <a:lstStyle/>
+          <a:p>
+            <a:r>
+              <a:t>En annexe, j'ai regroupe toutes mes sources : a gauche les aides et le financement - France Renov', MaPrimeRenov', le simulateur officiel, l'Anah, l'eco-PTZ et l'ASDER qui est l'agence locale de l'energie en Savoie. Au centre, les fournisseurs et marques des materiaux et equipements que j'ai retenus. A droite, les sources techniques et reglementaires : l'ADEME, la methode 3CL du DPE, Legifrance pour la reglementation, le geoportail de l'urbanisme, les statistiques de prix de l'energie et Meteo-France pour les donnees climatiques. Je me tiens a votre disposition si vous souhaitez des precisions sur l'une de ces sources.</a:t>
             </a:r>
           </a:p>
         </p:txBody>
@@ -26795,6 +26866,1491 @@
 </p:sld>
 </file>
 
+<file path=ppt/slides/slide23.xml><?xml version="1.0" encoding="utf-8"?>
+<p:sld xmlns:a="http://schemas.openxmlformats.org/drawingml/2006/main" xmlns:p="http://schemas.openxmlformats.org/presentationml/2006/main" xmlns:r="http://schemas.openxmlformats.org/officeDocument/2006/relationships">
+  <p:cSld>
+    <p:spTree>
+      <p:nvGrpSpPr>
+        <p:cNvPr id="1" name=""/>
+        <p:cNvGrpSpPr/>
+        <p:nvPr/>
+      </p:nvGrpSpPr>
+      <p:grpSpPr/>
+      <p:sp>
+        <p:nvSpPr>
+          <p:cNvPr id="2" name="Rectangle 1"/>
+          <p:cNvSpPr/>
+          <p:nvPr/>
+        </p:nvSpPr>
+        <p:spPr>
+          <a:xfrm>
+            <a:off x="0" y="0"/>
+            <a:ext cx="12191695" cy="6858000"/>
+          </a:xfrm>
+          <a:prstGeom prst="rect">
+            <a:avLst/>
+          </a:prstGeom>
+          <a:solidFill>
+            <a:srgbClr val="FFFFFF"/>
+          </a:solidFill>
+          <a:ln>
+            <a:noFill/>
+          </a:ln>
+          <a:effectLst/>
+        </p:spPr>
+        <p:style>
+          <a:lnRef idx="1">
+            <a:schemeClr val="accent1"/>
+          </a:lnRef>
+          <a:fillRef idx="3">
+            <a:schemeClr val="accent1"/>
+          </a:fillRef>
+          <a:effectRef idx="2">
+            <a:schemeClr val="accent1"/>
+          </a:effectRef>
+          <a:fontRef idx="minor">
+            <a:schemeClr val="lt1"/>
+          </a:fontRef>
+        </p:style>
+        <p:txBody>
+          <a:bodyPr rtlCol="0" anchor="ctr"/>
+          <a:lstStyle/>
+          <a:p>
+            <a:pPr algn="ctr"/>
+          </a:p>
+        </p:txBody>
+      </p:sp>
+      <p:sp>
+        <p:nvSpPr>
+          <p:cNvPr id="3" name="Rectangle 2"/>
+          <p:cNvSpPr/>
+          <p:nvPr/>
+        </p:nvSpPr>
+        <p:spPr>
+          <a:xfrm>
+            <a:off x="0" y="0"/>
+            <a:ext cx="201168" cy="6858000"/>
+          </a:xfrm>
+          <a:prstGeom prst="rect">
+            <a:avLst/>
+          </a:prstGeom>
+          <a:solidFill>
+            <a:srgbClr val="1B5E20"/>
+          </a:solidFill>
+          <a:ln>
+            <a:noFill/>
+          </a:ln>
+          <a:effectLst/>
+        </p:spPr>
+        <p:style>
+          <a:lnRef idx="1">
+            <a:schemeClr val="accent1"/>
+          </a:lnRef>
+          <a:fillRef idx="3">
+            <a:schemeClr val="accent1"/>
+          </a:fillRef>
+          <a:effectRef idx="2">
+            <a:schemeClr val="accent1"/>
+          </a:effectRef>
+          <a:fontRef idx="minor">
+            <a:schemeClr val="lt1"/>
+          </a:fontRef>
+        </p:style>
+        <p:txBody>
+          <a:bodyPr rtlCol="0" anchor="ctr"/>
+          <a:lstStyle/>
+          <a:p>
+            <a:pPr algn="ctr"/>
+          </a:p>
+        </p:txBody>
+      </p:sp>
+      <p:sp>
+        <p:nvSpPr>
+          <p:cNvPr id="4" name="TextBox 3"/>
+          <p:cNvSpPr txBox="1"/>
+          <p:nvPr/>
+        </p:nvSpPr>
+        <p:spPr>
+          <a:xfrm>
+            <a:off x="548640" y="365760"/>
+            <a:ext cx="10332720" cy="731520"/>
+          </a:xfrm>
+          <a:prstGeom prst="rect">
+            <a:avLst/>
+          </a:prstGeom>
+          <a:noFill/>
+        </p:spPr>
+        <p:txBody>
+          <a:bodyPr wrap="square" anchor="ctr" lIns="25400" rIns="25400" tIns="25400" bIns="25400">
+            <a:spAutoFit/>
+          </a:bodyPr>
+          <a:lstStyle/>
+          <a:p>
+            <a:pPr algn="l">
+              <a:lnSpc>
+                <a:spcPct val="100000"/>
+              </a:lnSpc>
+              <a:spcAft>
+                <a:spcPts val="400"/>
+              </a:spcAft>
+            </a:pPr>
+            <a:r>
+              <a:rPr sz="2800" b="1" i="0">
+                <a:solidFill>
+                  <a:srgbClr val="1B5E20"/>
+                </a:solidFill>
+                <a:latin typeface="Calibri"/>
+              </a:rPr>
+              <a:t>References &amp; sources</a:t>
+            </a:r>
+          </a:p>
+        </p:txBody>
+      </p:sp>
+      <p:sp>
+        <p:nvSpPr>
+          <p:cNvPr id="5" name="TextBox 4"/>
+          <p:cNvSpPr txBox="1"/>
+          <p:nvPr/>
+        </p:nvSpPr>
+        <p:spPr>
+          <a:xfrm>
+            <a:off x="548640" y="1042415"/>
+            <a:ext cx="10332720" cy="365760"/>
+          </a:xfrm>
+          <a:prstGeom prst="rect">
+            <a:avLst/>
+          </a:prstGeom>
+          <a:noFill/>
+        </p:spPr>
+        <p:txBody>
+          <a:bodyPr wrap="square" anchor="t" lIns="25400" rIns="25400" tIns="25400" bIns="25400">
+            <a:spAutoFit/>
+          </a:bodyPr>
+          <a:lstStyle/>
+          <a:p>
+            <a:pPr algn="l">
+              <a:lnSpc>
+                <a:spcPct val="100000"/>
+              </a:lnSpc>
+              <a:spcAft>
+                <a:spcPts val="400"/>
+              </a:spcAft>
+            </a:pPr>
+            <a:r>
+              <a:rPr sz="1400" b="0" i="1">
+                <a:solidFill>
+                  <a:srgbClr val="90A4AE"/>
+                </a:solidFill>
+                <a:latin typeface="Calibri"/>
+              </a:rPr>
+              <a:t>Annexe - aides, fournisseurs et donnees techniques</a:t>
+            </a:r>
+          </a:p>
+        </p:txBody>
+      </p:sp>
+      <p:sp>
+        <p:nvSpPr>
+          <p:cNvPr id="6" name="Rectangle 5"/>
+          <p:cNvSpPr/>
+          <p:nvPr/>
+        </p:nvSpPr>
+        <p:spPr>
+          <a:xfrm>
+            <a:off x="548640" y="1152144"/>
+            <a:ext cx="10058400" cy="27940"/>
+          </a:xfrm>
+          <a:prstGeom prst="rect">
+            <a:avLst/>
+          </a:prstGeom>
+          <a:solidFill>
+            <a:srgbClr val="2E7D32"/>
+          </a:solidFill>
+          <a:ln>
+            <a:noFill/>
+          </a:ln>
+          <a:effectLst/>
+        </p:spPr>
+        <p:style>
+          <a:lnRef idx="1">
+            <a:schemeClr val="accent1"/>
+          </a:lnRef>
+          <a:fillRef idx="3">
+            <a:schemeClr val="accent1"/>
+          </a:fillRef>
+          <a:effectRef idx="2">
+            <a:schemeClr val="accent1"/>
+          </a:effectRef>
+          <a:fontRef idx="minor">
+            <a:schemeClr val="lt1"/>
+          </a:fontRef>
+        </p:style>
+        <p:txBody>
+          <a:bodyPr rtlCol="0" anchor="ctr"/>
+          <a:lstStyle/>
+          <a:p>
+            <a:pPr algn="ctr"/>
+          </a:p>
+        </p:txBody>
+      </p:sp>
+      <p:sp>
+        <p:nvSpPr>
+          <p:cNvPr id="7" name="TextBox 6"/>
+          <p:cNvSpPr txBox="1"/>
+          <p:nvPr/>
+        </p:nvSpPr>
+        <p:spPr>
+          <a:xfrm>
+            <a:off x="502920" y="6473952"/>
+            <a:ext cx="8229600" cy="292608"/>
+          </a:xfrm>
+          <a:prstGeom prst="rect">
+            <a:avLst/>
+          </a:prstGeom>
+          <a:noFill/>
+        </p:spPr>
+        <p:txBody>
+          <a:bodyPr wrap="square" anchor="t" lIns="25400" rIns="25400" tIns="25400" bIns="25400">
+            <a:spAutoFit/>
+          </a:bodyPr>
+          <a:lstStyle/>
+          <a:p>
+            <a:pPr algn="l">
+              <a:lnSpc>
+                <a:spcPct val="100000"/>
+              </a:lnSpc>
+              <a:spcAft>
+                <a:spcPts val="400"/>
+              </a:spcAft>
+            </a:pPr>
+            <a:r>
+              <a:rPr sz="900" b="0" i="0">
+                <a:solidFill>
+                  <a:srgbClr val="90A4AE"/>
+                </a:solidFill>
+                <a:latin typeface="Calibri"/>
+              </a:rPr>
+              <a:t>Renovation energetique - Saint-Jean-de-Chevelu (73) - Bloc 1</a:t>
+            </a:r>
+          </a:p>
+        </p:txBody>
+      </p:sp>
+      <p:sp>
+        <p:nvSpPr>
+          <p:cNvPr id="8" name="TextBox 7"/>
+          <p:cNvSpPr txBox="1"/>
+          <p:nvPr/>
+        </p:nvSpPr>
+        <p:spPr>
+          <a:xfrm>
+            <a:off x="9418320" y="6473952"/>
+            <a:ext cx="2286000" cy="292608"/>
+          </a:xfrm>
+          <a:prstGeom prst="rect">
+            <a:avLst/>
+          </a:prstGeom>
+          <a:noFill/>
+        </p:spPr>
+        <p:txBody>
+          <a:bodyPr wrap="square" anchor="t" lIns="25400" rIns="25400" tIns="25400" bIns="25400">
+            <a:spAutoFit/>
+          </a:bodyPr>
+          <a:lstStyle/>
+          <a:p>
+            <a:pPr algn="r">
+              <a:lnSpc>
+                <a:spcPct val="100000"/>
+              </a:lnSpc>
+              <a:spcAft>
+                <a:spcPts val="400"/>
+              </a:spcAft>
+            </a:pPr>
+            <a:r>
+              <a:rPr sz="900" b="0" i="0">
+                <a:solidFill>
+                  <a:srgbClr val="90A4AE"/>
+                </a:solidFill>
+                <a:latin typeface="Calibri"/>
+              </a:rPr>
+              <a:t>Guillaume Tardy</a:t>
+            </a:r>
+          </a:p>
+        </p:txBody>
+      </p:sp>
+      <p:sp>
+        <p:nvSpPr>
+          <p:cNvPr id="9" name="Rounded Rectangle 8"/>
+          <p:cNvSpPr/>
+          <p:nvPr/>
+        </p:nvSpPr>
+        <p:spPr>
+          <a:xfrm>
+            <a:off x="548640" y="1508760"/>
+            <a:ext cx="3611880" cy="4709160"/>
+          </a:xfrm>
+          <a:prstGeom prst="roundRect">
+            <a:avLst/>
+          </a:prstGeom>
+          <a:solidFill>
+            <a:srgbClr val="FFFFFF"/>
+          </a:solidFill>
+          <a:ln w="12700">
+            <a:solidFill>
+              <a:srgbClr val="90A4AE"/>
+            </a:solidFill>
+          </a:ln>
+          <a:effectLst/>
+        </p:spPr>
+        <p:style>
+          <a:lnRef idx="1">
+            <a:schemeClr val="accent1"/>
+          </a:lnRef>
+          <a:fillRef idx="3">
+            <a:schemeClr val="accent1"/>
+          </a:fillRef>
+          <a:effectRef idx="2">
+            <a:schemeClr val="accent1"/>
+          </a:effectRef>
+          <a:fontRef idx="minor">
+            <a:schemeClr val="lt1"/>
+          </a:fontRef>
+        </p:style>
+        <p:txBody>
+          <a:bodyPr rtlCol="0" anchor="ctr"/>
+          <a:lstStyle/>
+          <a:p>
+            <a:pPr algn="ctr"/>
+          </a:p>
+        </p:txBody>
+      </p:sp>
+      <p:sp>
+        <p:nvSpPr>
+          <p:cNvPr id="10" name="Rounded Rectangle 9"/>
+          <p:cNvSpPr/>
+          <p:nvPr/>
+        </p:nvSpPr>
+        <p:spPr>
+          <a:xfrm>
+            <a:off x="548640" y="1508760"/>
+            <a:ext cx="3611880" cy="502920"/>
+          </a:xfrm>
+          <a:prstGeom prst="roundRect">
+            <a:avLst/>
+          </a:prstGeom>
+          <a:solidFill>
+            <a:srgbClr val="1B5E20"/>
+          </a:solidFill>
+          <a:ln>
+            <a:noFill/>
+          </a:ln>
+          <a:effectLst/>
+        </p:spPr>
+        <p:style>
+          <a:lnRef idx="1">
+            <a:schemeClr val="accent1"/>
+          </a:lnRef>
+          <a:fillRef idx="3">
+            <a:schemeClr val="accent1"/>
+          </a:fillRef>
+          <a:effectRef idx="2">
+            <a:schemeClr val="accent1"/>
+          </a:effectRef>
+          <a:fontRef idx="minor">
+            <a:schemeClr val="lt1"/>
+          </a:fontRef>
+        </p:style>
+        <p:txBody>
+          <a:bodyPr rtlCol="0" anchor="ctr"/>
+          <a:lstStyle/>
+          <a:p>
+            <a:pPr algn="ctr"/>
+          </a:p>
+        </p:txBody>
+      </p:sp>
+      <p:sp>
+        <p:nvSpPr>
+          <p:cNvPr id="11" name="TextBox 10"/>
+          <p:cNvSpPr txBox="1"/>
+          <p:nvPr/>
+        </p:nvSpPr>
+        <p:spPr>
+          <a:xfrm>
+            <a:off x="548640" y="1508760"/>
+            <a:ext cx="3611880" cy="502920"/>
+          </a:xfrm>
+          <a:prstGeom prst="rect">
+            <a:avLst/>
+          </a:prstGeom>
+          <a:noFill/>
+        </p:spPr>
+        <p:txBody>
+          <a:bodyPr wrap="square" anchor="ctr" lIns="25400" rIns="25400" tIns="25400" bIns="25400">
+            <a:spAutoFit/>
+          </a:bodyPr>
+          <a:lstStyle/>
+          <a:p>
+            <a:pPr algn="ctr">
+              <a:lnSpc>
+                <a:spcPct val="100000"/>
+              </a:lnSpc>
+              <a:spcAft>
+                <a:spcPts val="400"/>
+              </a:spcAft>
+            </a:pPr>
+            <a:r>
+              <a:rPr sz="1400" b="1" i="0">
+                <a:solidFill>
+                  <a:srgbClr val="FFFFFF"/>
+                </a:solidFill>
+                <a:latin typeface="Calibri"/>
+              </a:rPr>
+              <a:t>Aides &amp; financement</a:t>
+            </a:r>
+          </a:p>
+        </p:txBody>
+      </p:sp>
+      <p:sp>
+        <p:nvSpPr>
+          <p:cNvPr id="12" name="TextBox 11"/>
+          <p:cNvSpPr txBox="1"/>
+          <p:nvPr/>
+        </p:nvSpPr>
+        <p:spPr>
+          <a:xfrm>
+            <a:off x="713232" y="2148840"/>
+            <a:ext cx="3300984" cy="3931920"/>
+          </a:xfrm>
+          <a:prstGeom prst="rect">
+            <a:avLst/>
+          </a:prstGeom>
+          <a:noFill/>
+        </p:spPr>
+        <p:txBody>
+          <a:bodyPr wrap="square">
+            <a:spAutoFit/>
+          </a:bodyPr>
+          <a:lstStyle/>
+          <a:p>
+            <a:pPr>
+              <a:lnSpc>
+                <a:spcPct val="100000"/>
+              </a:lnSpc>
+              <a:spcAft>
+                <a:spcPts val="600"/>
+              </a:spcAft>
+            </a:pPr>
+            <a:r>
+              <a:rPr sz="1100" b="1">
+                <a:solidFill>
+                  <a:srgbClr val="37474F"/>
+                </a:solidFill>
+                <a:latin typeface="Calibri"/>
+              </a:rPr>
+              <a:t>France Renov' (service public) </a:t>
+            </a:r>
+          </a:p>
+          <a:p>
+            <a:pPr>
+              <a:lnSpc>
+                <a:spcPct val="100000"/>
+              </a:lnSpc>
+              <a:spcAft>
+                <a:spcPts val="600"/>
+              </a:spcAft>
+            </a:pPr>
+            <a:r>
+              <a:rPr sz="1050">
+                <a:solidFill>
+                  <a:srgbClr val="1565C0"/>
+                </a:solidFill>
+                <a:latin typeface="Calibri"/>
+                <a:hlinkClick r:id="rId2"/>
+              </a:rPr>
+              <a:t>france-renov.gouv.fr</a:t>
+            </a:r>
+          </a:p>
+          <a:p>
+            <a:pPr>
+              <a:lnSpc>
+                <a:spcPct val="100000"/>
+              </a:lnSpc>
+              <a:spcAft>
+                <a:spcPts val="600"/>
+              </a:spcAft>
+            </a:pPr>
+            <a:r>
+              <a:rPr sz="1100" b="1">
+                <a:solidFill>
+                  <a:srgbClr val="37474F"/>
+                </a:solidFill>
+                <a:latin typeface="Calibri"/>
+              </a:rPr>
+              <a:t>MaPrimeRenov' </a:t>
+            </a:r>
+          </a:p>
+          <a:p>
+            <a:pPr>
+              <a:lnSpc>
+                <a:spcPct val="100000"/>
+              </a:lnSpc>
+              <a:spcAft>
+                <a:spcPts val="600"/>
+              </a:spcAft>
+            </a:pPr>
+            <a:r>
+              <a:rPr sz="1050">
+                <a:solidFill>
+                  <a:srgbClr val="1565C0"/>
+                </a:solidFill>
+                <a:latin typeface="Calibri"/>
+                <a:hlinkClick r:id="rId3"/>
+              </a:rPr>
+              <a:t>maprimerenov.gouv.fr</a:t>
+            </a:r>
+          </a:p>
+          <a:p>
+            <a:pPr>
+              <a:lnSpc>
+                <a:spcPct val="100000"/>
+              </a:lnSpc>
+              <a:spcAft>
+                <a:spcPts val="600"/>
+              </a:spcAft>
+            </a:pPr>
+            <a:r>
+              <a:rPr sz="1100" b="1">
+                <a:solidFill>
+                  <a:srgbClr val="37474F"/>
+                </a:solidFill>
+                <a:latin typeface="Calibri"/>
+              </a:rPr>
+              <a:t>Simulateur d'aides </a:t>
+            </a:r>
+          </a:p>
+          <a:p>
+            <a:pPr>
+              <a:lnSpc>
+                <a:spcPct val="100000"/>
+              </a:lnSpc>
+              <a:spcAft>
+                <a:spcPts val="600"/>
+              </a:spcAft>
+            </a:pPr>
+            <a:r>
+              <a:rPr sz="1050">
+                <a:solidFill>
+                  <a:srgbClr val="1565C0"/>
+                </a:solidFill>
+                <a:latin typeface="Calibri"/>
+                <a:hlinkClick r:id="rId4"/>
+              </a:rPr>
+              <a:t>mesaidesreno.gouv.fr</a:t>
+            </a:r>
+          </a:p>
+          <a:p>
+            <a:pPr>
+              <a:lnSpc>
+                <a:spcPct val="100000"/>
+              </a:lnSpc>
+              <a:spcAft>
+                <a:spcPts val="600"/>
+              </a:spcAft>
+            </a:pPr>
+            <a:r>
+              <a:rPr sz="1100" b="1">
+                <a:solidFill>
+                  <a:srgbClr val="37474F"/>
+                </a:solidFill>
+                <a:latin typeface="Calibri"/>
+              </a:rPr>
+              <a:t>Anah </a:t>
+            </a:r>
+          </a:p>
+          <a:p>
+            <a:pPr>
+              <a:lnSpc>
+                <a:spcPct val="100000"/>
+              </a:lnSpc>
+              <a:spcAft>
+                <a:spcPts val="600"/>
+              </a:spcAft>
+            </a:pPr>
+            <a:r>
+              <a:rPr sz="1050">
+                <a:solidFill>
+                  <a:srgbClr val="1565C0"/>
+                </a:solidFill>
+                <a:latin typeface="Calibri"/>
+                <a:hlinkClick r:id="rId5"/>
+              </a:rPr>
+              <a:t>anah.gouv.fr</a:t>
+            </a:r>
+          </a:p>
+          <a:p>
+            <a:pPr>
+              <a:lnSpc>
+                <a:spcPct val="100000"/>
+              </a:lnSpc>
+              <a:spcAft>
+                <a:spcPts val="600"/>
+              </a:spcAft>
+            </a:pPr>
+            <a:r>
+              <a:rPr sz="1100" b="1">
+                <a:solidFill>
+                  <a:srgbClr val="37474F"/>
+                </a:solidFill>
+                <a:latin typeface="Calibri"/>
+              </a:rPr>
+              <a:t>Eco-PTZ &amp; CEE </a:t>
+            </a:r>
+          </a:p>
+          <a:p>
+            <a:pPr>
+              <a:lnSpc>
+                <a:spcPct val="100000"/>
+              </a:lnSpc>
+              <a:spcAft>
+                <a:spcPts val="600"/>
+              </a:spcAft>
+            </a:pPr>
+            <a:r>
+              <a:rPr sz="1050">
+                <a:solidFill>
+                  <a:srgbClr val="1565C0"/>
+                </a:solidFill>
+                <a:latin typeface="Calibri"/>
+                <a:hlinkClick r:id="rId6"/>
+              </a:rPr>
+              <a:t>service-public.fr</a:t>
+            </a:r>
+          </a:p>
+          <a:p>
+            <a:pPr>
+              <a:lnSpc>
+                <a:spcPct val="100000"/>
+              </a:lnSpc>
+              <a:spcAft>
+                <a:spcPts val="600"/>
+              </a:spcAft>
+            </a:pPr>
+            <a:r>
+              <a:rPr sz="1100" b="1">
+                <a:solidFill>
+                  <a:srgbClr val="37474F"/>
+                </a:solidFill>
+                <a:latin typeface="Calibri"/>
+              </a:rPr>
+              <a:t>ASDER - espace conseil (Savoie) </a:t>
+            </a:r>
+          </a:p>
+          <a:p>
+            <a:pPr>
+              <a:lnSpc>
+                <a:spcPct val="100000"/>
+              </a:lnSpc>
+              <a:spcAft>
+                <a:spcPts val="600"/>
+              </a:spcAft>
+            </a:pPr>
+            <a:r>
+              <a:rPr sz="1050">
+                <a:solidFill>
+                  <a:srgbClr val="1565C0"/>
+                </a:solidFill>
+                <a:latin typeface="Calibri"/>
+                <a:hlinkClick r:id="rId7"/>
+              </a:rPr>
+              <a:t>asder.asso.fr</a:t>
+            </a:r>
+          </a:p>
+        </p:txBody>
+      </p:sp>
+      <p:sp>
+        <p:nvSpPr>
+          <p:cNvPr id="13" name="Rounded Rectangle 12"/>
+          <p:cNvSpPr/>
+          <p:nvPr/>
+        </p:nvSpPr>
+        <p:spPr>
+          <a:xfrm>
+            <a:off x="4297680" y="1508760"/>
+            <a:ext cx="3611880" cy="4709160"/>
+          </a:xfrm>
+          <a:prstGeom prst="roundRect">
+            <a:avLst/>
+          </a:prstGeom>
+          <a:solidFill>
+            <a:srgbClr val="FFFFFF"/>
+          </a:solidFill>
+          <a:ln w="12700">
+            <a:solidFill>
+              <a:srgbClr val="90A4AE"/>
+            </a:solidFill>
+          </a:ln>
+          <a:effectLst/>
+        </p:spPr>
+        <p:style>
+          <a:lnRef idx="1">
+            <a:schemeClr val="accent1"/>
+          </a:lnRef>
+          <a:fillRef idx="3">
+            <a:schemeClr val="accent1"/>
+          </a:fillRef>
+          <a:effectRef idx="2">
+            <a:schemeClr val="accent1"/>
+          </a:effectRef>
+          <a:fontRef idx="minor">
+            <a:schemeClr val="lt1"/>
+          </a:fontRef>
+        </p:style>
+        <p:txBody>
+          <a:bodyPr rtlCol="0" anchor="ctr"/>
+          <a:lstStyle/>
+          <a:p>
+            <a:pPr algn="ctr"/>
+          </a:p>
+        </p:txBody>
+      </p:sp>
+      <p:sp>
+        <p:nvSpPr>
+          <p:cNvPr id="14" name="Rounded Rectangle 13"/>
+          <p:cNvSpPr/>
+          <p:nvPr/>
+        </p:nvSpPr>
+        <p:spPr>
+          <a:xfrm>
+            <a:off x="4297680" y="1508760"/>
+            <a:ext cx="3611880" cy="502920"/>
+          </a:xfrm>
+          <a:prstGeom prst="roundRect">
+            <a:avLst/>
+          </a:prstGeom>
+          <a:solidFill>
+            <a:srgbClr val="1565C0"/>
+          </a:solidFill>
+          <a:ln>
+            <a:noFill/>
+          </a:ln>
+          <a:effectLst/>
+        </p:spPr>
+        <p:style>
+          <a:lnRef idx="1">
+            <a:schemeClr val="accent1"/>
+          </a:lnRef>
+          <a:fillRef idx="3">
+            <a:schemeClr val="accent1"/>
+          </a:fillRef>
+          <a:effectRef idx="2">
+            <a:schemeClr val="accent1"/>
+          </a:effectRef>
+          <a:fontRef idx="minor">
+            <a:schemeClr val="lt1"/>
+          </a:fontRef>
+        </p:style>
+        <p:txBody>
+          <a:bodyPr rtlCol="0" anchor="ctr"/>
+          <a:lstStyle/>
+          <a:p>
+            <a:pPr algn="ctr"/>
+          </a:p>
+        </p:txBody>
+      </p:sp>
+      <p:sp>
+        <p:nvSpPr>
+          <p:cNvPr id="15" name="TextBox 14"/>
+          <p:cNvSpPr txBox="1"/>
+          <p:nvPr/>
+        </p:nvSpPr>
+        <p:spPr>
+          <a:xfrm>
+            <a:off x="4297680" y="1508760"/>
+            <a:ext cx="3611880" cy="502920"/>
+          </a:xfrm>
+          <a:prstGeom prst="rect">
+            <a:avLst/>
+          </a:prstGeom>
+          <a:noFill/>
+        </p:spPr>
+        <p:txBody>
+          <a:bodyPr wrap="square" anchor="ctr" lIns="25400" rIns="25400" tIns="25400" bIns="25400">
+            <a:spAutoFit/>
+          </a:bodyPr>
+          <a:lstStyle/>
+          <a:p>
+            <a:pPr algn="ctr">
+              <a:lnSpc>
+                <a:spcPct val="100000"/>
+              </a:lnSpc>
+              <a:spcAft>
+                <a:spcPts val="400"/>
+              </a:spcAft>
+            </a:pPr>
+            <a:r>
+              <a:rPr sz="1400" b="1" i="0">
+                <a:solidFill>
+                  <a:srgbClr val="FFFFFF"/>
+                </a:solidFill>
+                <a:latin typeface="Calibri"/>
+              </a:rPr>
+              <a:t>Materiaux &amp; equipements</a:t>
+            </a:r>
+          </a:p>
+        </p:txBody>
+      </p:sp>
+      <p:sp>
+        <p:nvSpPr>
+          <p:cNvPr id="16" name="TextBox 15"/>
+          <p:cNvSpPr txBox="1"/>
+          <p:nvPr/>
+        </p:nvSpPr>
+        <p:spPr>
+          <a:xfrm>
+            <a:off x="4462272" y="2148840"/>
+            <a:ext cx="3300984" cy="3931920"/>
+          </a:xfrm>
+          <a:prstGeom prst="rect">
+            <a:avLst/>
+          </a:prstGeom>
+          <a:noFill/>
+        </p:spPr>
+        <p:txBody>
+          <a:bodyPr wrap="square">
+            <a:spAutoFit/>
+          </a:bodyPr>
+          <a:lstStyle/>
+          <a:p>
+            <a:pPr>
+              <a:lnSpc>
+                <a:spcPct val="100000"/>
+              </a:lnSpc>
+              <a:spcAft>
+                <a:spcPts val="600"/>
+              </a:spcAft>
+            </a:pPr>
+            <a:r>
+              <a:rPr sz="1100" b="1">
+                <a:solidFill>
+                  <a:srgbClr val="37474F"/>
+                </a:solidFill>
+                <a:latin typeface="Calibri"/>
+              </a:rPr>
+              <a:t>Laine de bois (ITE) </a:t>
+            </a:r>
+          </a:p>
+          <a:p>
+            <a:pPr>
+              <a:lnSpc>
+                <a:spcPct val="100000"/>
+              </a:lnSpc>
+              <a:spcAft>
+                <a:spcPts val="600"/>
+              </a:spcAft>
+            </a:pPr>
+            <a:r>
+              <a:rPr sz="1050">
+                <a:solidFill>
+                  <a:srgbClr val="1565C0"/>
+                </a:solidFill>
+                <a:latin typeface="Calibri"/>
+                <a:hlinkClick r:id="rId8"/>
+              </a:rPr>
+              <a:t>steico.com  -  soprema.fr</a:t>
+            </a:r>
+          </a:p>
+          <a:p>
+            <a:pPr>
+              <a:lnSpc>
+                <a:spcPct val="100000"/>
+              </a:lnSpc>
+              <a:spcAft>
+                <a:spcPts val="600"/>
+              </a:spcAft>
+            </a:pPr>
+            <a:r>
+              <a:rPr sz="1100" b="1">
+                <a:solidFill>
+                  <a:srgbClr val="37474F"/>
+                </a:solidFill>
+                <a:latin typeface="Calibri"/>
+              </a:rPr>
+              <a:t>Ouate de cellulose </a:t>
+            </a:r>
+          </a:p>
+          <a:p>
+            <a:pPr>
+              <a:lnSpc>
+                <a:spcPct val="100000"/>
+              </a:lnSpc>
+              <a:spcAft>
+                <a:spcPts val="600"/>
+              </a:spcAft>
+            </a:pPr>
+            <a:r>
+              <a:rPr sz="1050">
+                <a:solidFill>
+                  <a:srgbClr val="1565C0"/>
+                </a:solidFill>
+                <a:latin typeface="Calibri"/>
+                <a:hlinkClick r:id="rId9"/>
+              </a:rPr>
+              <a:t>ouateco.com  -  isocell.com</a:t>
+            </a:r>
+          </a:p>
+          <a:p>
+            <a:pPr>
+              <a:lnSpc>
+                <a:spcPct val="100000"/>
+              </a:lnSpc>
+              <a:spcAft>
+                <a:spcPts val="600"/>
+              </a:spcAft>
+            </a:pPr>
+            <a:r>
+              <a:rPr sz="1100" b="1">
+                <a:solidFill>
+                  <a:srgbClr val="37474F"/>
+                </a:solidFill>
+                <a:latin typeface="Calibri"/>
+              </a:rPr>
+              <a:t>VMC hygro B </a:t>
+            </a:r>
+          </a:p>
+          <a:p>
+            <a:pPr>
+              <a:lnSpc>
+                <a:spcPct val="100000"/>
+              </a:lnSpc>
+              <a:spcAft>
+                <a:spcPts val="600"/>
+              </a:spcAft>
+            </a:pPr>
+            <a:r>
+              <a:rPr sz="1050">
+                <a:solidFill>
+                  <a:srgbClr val="1565C0"/>
+                </a:solidFill>
+                <a:latin typeface="Calibri"/>
+                <a:hlinkClick r:id="rId10"/>
+              </a:rPr>
+              <a:t>aldes.fr  -  atlantic.fr</a:t>
+            </a:r>
+          </a:p>
+          <a:p>
+            <a:pPr>
+              <a:lnSpc>
+                <a:spcPct val="100000"/>
+              </a:lnSpc>
+              <a:spcAft>
+                <a:spcPts val="600"/>
+              </a:spcAft>
+            </a:pPr>
+            <a:r>
+              <a:rPr sz="1100" b="1">
+                <a:solidFill>
+                  <a:srgbClr val="37474F"/>
+                </a:solidFill>
+                <a:latin typeface="Calibri"/>
+              </a:rPr>
+              <a:t>Chauffe-eau thermodynamique </a:t>
+            </a:r>
+          </a:p>
+          <a:p>
+            <a:pPr>
+              <a:lnSpc>
+                <a:spcPct val="100000"/>
+              </a:lnSpc>
+              <a:spcAft>
+                <a:spcPts val="600"/>
+              </a:spcAft>
+            </a:pPr>
+            <a:r>
+              <a:rPr sz="1050">
+                <a:solidFill>
+                  <a:srgbClr val="1565C0"/>
+                </a:solidFill>
+                <a:latin typeface="Calibri"/>
+                <a:hlinkClick r:id="rId11"/>
+              </a:rPr>
+              <a:t>atlantic.fr  -  thermor.fr</a:t>
+            </a:r>
+          </a:p>
+          <a:p>
+            <a:pPr>
+              <a:lnSpc>
+                <a:spcPct val="100000"/>
+              </a:lnSpc>
+              <a:spcAft>
+                <a:spcPts val="600"/>
+              </a:spcAft>
+            </a:pPr>
+            <a:r>
+              <a:rPr sz="1100" b="1">
+                <a:solidFill>
+                  <a:srgbClr val="37474F"/>
+                </a:solidFill>
+                <a:latin typeface="Calibri"/>
+              </a:rPr>
+              <a:t>Chaudiere a granules </a:t>
+            </a:r>
+          </a:p>
+          <a:p>
+            <a:pPr>
+              <a:lnSpc>
+                <a:spcPct val="100000"/>
+              </a:lnSpc>
+              <a:spcAft>
+                <a:spcPts val="600"/>
+              </a:spcAft>
+            </a:pPr>
+            <a:r>
+              <a:rPr sz="1050">
+                <a:solidFill>
+                  <a:srgbClr val="1565C0"/>
+                </a:solidFill>
+                <a:latin typeface="Calibri"/>
+                <a:hlinkClick r:id="rId12"/>
+              </a:rPr>
+              <a:t>oekofen.com  -  hargassner.com</a:t>
+            </a:r>
+          </a:p>
+          <a:p>
+            <a:pPr>
+              <a:lnSpc>
+                <a:spcPct val="100000"/>
+              </a:lnSpc>
+              <a:spcAft>
+                <a:spcPts val="600"/>
+              </a:spcAft>
+            </a:pPr>
+            <a:r>
+              <a:rPr sz="1100" b="1">
+                <a:solidFill>
+                  <a:srgbClr val="37474F"/>
+                </a:solidFill>
+                <a:latin typeface="Calibri"/>
+              </a:rPr>
+              <a:t>Enduit / finition ITE </a:t>
+            </a:r>
+          </a:p>
+          <a:p>
+            <a:pPr>
+              <a:lnSpc>
+                <a:spcPct val="100000"/>
+              </a:lnSpc>
+              <a:spcAft>
+                <a:spcPts val="600"/>
+              </a:spcAft>
+            </a:pPr>
+            <a:r>
+              <a:rPr sz="1050">
+                <a:solidFill>
+                  <a:srgbClr val="1565C0"/>
+                </a:solidFill>
+                <a:latin typeface="Calibri"/>
+                <a:hlinkClick r:id="rId13"/>
+              </a:rPr>
+              <a:t>fr.weber  -  parexlanko.com</a:t>
+            </a:r>
+          </a:p>
+        </p:txBody>
+      </p:sp>
+      <p:sp>
+        <p:nvSpPr>
+          <p:cNvPr id="17" name="Rounded Rectangle 16"/>
+          <p:cNvSpPr/>
+          <p:nvPr/>
+        </p:nvSpPr>
+        <p:spPr>
+          <a:xfrm>
+            <a:off x="8046720" y="1508760"/>
+            <a:ext cx="3611880" cy="4709160"/>
+          </a:xfrm>
+          <a:prstGeom prst="roundRect">
+            <a:avLst/>
+          </a:prstGeom>
+          <a:solidFill>
+            <a:srgbClr val="FFFFFF"/>
+          </a:solidFill>
+          <a:ln w="12700">
+            <a:solidFill>
+              <a:srgbClr val="90A4AE"/>
+            </a:solidFill>
+          </a:ln>
+          <a:effectLst/>
+        </p:spPr>
+        <p:style>
+          <a:lnRef idx="1">
+            <a:schemeClr val="accent1"/>
+          </a:lnRef>
+          <a:fillRef idx="3">
+            <a:schemeClr val="accent1"/>
+          </a:fillRef>
+          <a:effectRef idx="2">
+            <a:schemeClr val="accent1"/>
+          </a:effectRef>
+          <a:fontRef idx="minor">
+            <a:schemeClr val="lt1"/>
+          </a:fontRef>
+        </p:style>
+        <p:txBody>
+          <a:bodyPr rtlCol="0" anchor="ctr"/>
+          <a:lstStyle/>
+          <a:p>
+            <a:pPr algn="ctr"/>
+          </a:p>
+        </p:txBody>
+      </p:sp>
+      <p:sp>
+        <p:nvSpPr>
+          <p:cNvPr id="18" name="Rounded Rectangle 17"/>
+          <p:cNvSpPr/>
+          <p:nvPr/>
+        </p:nvSpPr>
+        <p:spPr>
+          <a:xfrm>
+            <a:off x="8046720" y="1508760"/>
+            <a:ext cx="3611880" cy="502920"/>
+          </a:xfrm>
+          <a:prstGeom prst="roundRect">
+            <a:avLst/>
+          </a:prstGeom>
+          <a:solidFill>
+            <a:srgbClr val="E65100"/>
+          </a:solidFill>
+          <a:ln>
+            <a:noFill/>
+          </a:ln>
+          <a:effectLst/>
+        </p:spPr>
+        <p:style>
+          <a:lnRef idx="1">
+            <a:schemeClr val="accent1"/>
+          </a:lnRef>
+          <a:fillRef idx="3">
+            <a:schemeClr val="accent1"/>
+          </a:fillRef>
+          <a:effectRef idx="2">
+            <a:schemeClr val="accent1"/>
+          </a:effectRef>
+          <a:fontRef idx="minor">
+            <a:schemeClr val="lt1"/>
+          </a:fontRef>
+        </p:style>
+        <p:txBody>
+          <a:bodyPr rtlCol="0" anchor="ctr"/>
+          <a:lstStyle/>
+          <a:p>
+            <a:pPr algn="ctr"/>
+          </a:p>
+        </p:txBody>
+      </p:sp>
+      <p:sp>
+        <p:nvSpPr>
+          <p:cNvPr id="19" name="TextBox 18"/>
+          <p:cNvSpPr txBox="1"/>
+          <p:nvPr/>
+        </p:nvSpPr>
+        <p:spPr>
+          <a:xfrm>
+            <a:off x="8046720" y="1508760"/>
+            <a:ext cx="3611880" cy="502920"/>
+          </a:xfrm>
+          <a:prstGeom prst="rect">
+            <a:avLst/>
+          </a:prstGeom>
+          <a:noFill/>
+        </p:spPr>
+        <p:txBody>
+          <a:bodyPr wrap="square" anchor="ctr" lIns="25400" rIns="25400" tIns="25400" bIns="25400">
+            <a:spAutoFit/>
+          </a:bodyPr>
+          <a:lstStyle/>
+          <a:p>
+            <a:pPr algn="ctr">
+              <a:lnSpc>
+                <a:spcPct val="100000"/>
+              </a:lnSpc>
+              <a:spcAft>
+                <a:spcPts val="400"/>
+              </a:spcAft>
+            </a:pPr>
+            <a:r>
+              <a:rPr sz="1400" b="1" i="0">
+                <a:solidFill>
+                  <a:srgbClr val="FFFFFF"/>
+                </a:solidFill>
+                <a:latin typeface="Calibri"/>
+              </a:rPr>
+              <a:t>Donnees &amp; reglementation</a:t>
+            </a:r>
+          </a:p>
+        </p:txBody>
+      </p:sp>
+      <p:sp>
+        <p:nvSpPr>
+          <p:cNvPr id="20" name="TextBox 19"/>
+          <p:cNvSpPr txBox="1"/>
+          <p:nvPr/>
+        </p:nvSpPr>
+        <p:spPr>
+          <a:xfrm>
+            <a:off x="8211312" y="2148840"/>
+            <a:ext cx="3300984" cy="3931920"/>
+          </a:xfrm>
+          <a:prstGeom prst="rect">
+            <a:avLst/>
+          </a:prstGeom>
+          <a:noFill/>
+        </p:spPr>
+        <p:txBody>
+          <a:bodyPr wrap="square">
+            <a:spAutoFit/>
+          </a:bodyPr>
+          <a:lstStyle/>
+          <a:p>
+            <a:pPr>
+              <a:lnSpc>
+                <a:spcPct val="100000"/>
+              </a:lnSpc>
+              <a:spcAft>
+                <a:spcPts val="600"/>
+              </a:spcAft>
+            </a:pPr>
+            <a:r>
+              <a:rPr sz="1100" b="1">
+                <a:solidFill>
+                  <a:srgbClr val="37474F"/>
+                </a:solidFill>
+                <a:latin typeface="Calibri"/>
+              </a:rPr>
+              <a:t>ADEME (energie / climat) </a:t>
+            </a:r>
+          </a:p>
+          <a:p>
+            <a:pPr>
+              <a:lnSpc>
+                <a:spcPct val="100000"/>
+              </a:lnSpc>
+              <a:spcAft>
+                <a:spcPts val="600"/>
+              </a:spcAft>
+            </a:pPr>
+            <a:r>
+              <a:rPr sz="1050">
+                <a:solidFill>
+                  <a:srgbClr val="1565C0"/>
+                </a:solidFill>
+                <a:latin typeface="Calibri"/>
+                <a:hlinkClick r:id="rId14"/>
+              </a:rPr>
+              <a:t>ademe.fr</a:t>
+            </a:r>
+          </a:p>
+          <a:p>
+            <a:pPr>
+              <a:lnSpc>
+                <a:spcPct val="100000"/>
+              </a:lnSpc>
+              <a:spcAft>
+                <a:spcPts val="600"/>
+              </a:spcAft>
+            </a:pPr>
+            <a:r>
+              <a:rPr sz="1100" b="1">
+                <a:solidFill>
+                  <a:srgbClr val="37474F"/>
+                </a:solidFill>
+                <a:latin typeface="Calibri"/>
+              </a:rPr>
+              <a:t>DPE - methode 3CL &amp; observatoire </a:t>
+            </a:r>
+          </a:p>
+          <a:p>
+            <a:pPr>
+              <a:lnSpc>
+                <a:spcPct val="100000"/>
+              </a:lnSpc>
+              <a:spcAft>
+                <a:spcPts val="600"/>
+              </a:spcAft>
+            </a:pPr>
+            <a:r>
+              <a:rPr sz="1050">
+                <a:solidFill>
+                  <a:srgbClr val="1565C0"/>
+                </a:solidFill>
+                <a:latin typeface="Calibri"/>
+                <a:hlinkClick r:id="rId15"/>
+              </a:rPr>
+              <a:t>observatoire-dpe-audit.ademe.fr</a:t>
+            </a:r>
+          </a:p>
+          <a:p>
+            <a:pPr>
+              <a:lnSpc>
+                <a:spcPct val="100000"/>
+              </a:lnSpc>
+              <a:spcAft>
+                <a:spcPts val="600"/>
+              </a:spcAft>
+            </a:pPr>
+            <a:r>
+              <a:rPr sz="1100" b="1">
+                <a:solidFill>
+                  <a:srgbClr val="37474F"/>
+                </a:solidFill>
+                <a:latin typeface="Calibri"/>
+              </a:rPr>
+              <a:t>Reglementation (CCH, arretes DPE) </a:t>
+            </a:r>
+          </a:p>
+          <a:p>
+            <a:pPr>
+              <a:lnSpc>
+                <a:spcPct val="100000"/>
+              </a:lnSpc>
+              <a:spcAft>
+                <a:spcPts val="600"/>
+              </a:spcAft>
+            </a:pPr>
+            <a:r>
+              <a:rPr sz="1050">
+                <a:solidFill>
+                  <a:srgbClr val="1565C0"/>
+                </a:solidFill>
+                <a:latin typeface="Calibri"/>
+                <a:hlinkClick r:id="rId16"/>
+              </a:rPr>
+              <a:t>legifrance.gouv.fr</a:t>
+            </a:r>
+          </a:p>
+          <a:p>
+            <a:pPr>
+              <a:lnSpc>
+                <a:spcPct val="100000"/>
+              </a:lnSpc>
+              <a:spcAft>
+                <a:spcPts val="600"/>
+              </a:spcAft>
+            </a:pPr>
+            <a:r>
+              <a:rPr sz="1100" b="1">
+                <a:solidFill>
+                  <a:srgbClr val="37474F"/>
+                </a:solidFill>
+                <a:latin typeface="Calibri"/>
+              </a:rPr>
+              <a:t>Urbanisme / PLU (declaration prealable) </a:t>
+            </a:r>
+          </a:p>
+          <a:p>
+            <a:pPr>
+              <a:lnSpc>
+                <a:spcPct val="100000"/>
+              </a:lnSpc>
+              <a:spcAft>
+                <a:spcPts val="600"/>
+              </a:spcAft>
+            </a:pPr>
+            <a:r>
+              <a:rPr sz="1050">
+                <a:solidFill>
+                  <a:srgbClr val="1565C0"/>
+                </a:solidFill>
+                <a:latin typeface="Calibri"/>
+                <a:hlinkClick r:id="rId17"/>
+              </a:rPr>
+              <a:t>geoportail-urbanisme.gouv.fr</a:t>
+            </a:r>
+          </a:p>
+          <a:p>
+            <a:pPr>
+              <a:lnSpc>
+                <a:spcPct val="100000"/>
+              </a:lnSpc>
+              <a:spcAft>
+                <a:spcPts val="600"/>
+              </a:spcAft>
+            </a:pPr>
+            <a:r>
+              <a:rPr sz="1100" b="1">
+                <a:solidFill>
+                  <a:srgbClr val="37474F"/>
+                </a:solidFill>
+                <a:latin typeface="Calibri"/>
+              </a:rPr>
+              <a:t>Prix de l'energie (statistiques) </a:t>
+            </a:r>
+          </a:p>
+          <a:p>
+            <a:pPr>
+              <a:lnSpc>
+                <a:spcPct val="100000"/>
+              </a:lnSpc>
+              <a:spcAft>
+                <a:spcPts val="600"/>
+              </a:spcAft>
+            </a:pPr>
+            <a:r>
+              <a:rPr sz="1050">
+                <a:solidFill>
+                  <a:srgbClr val="1565C0"/>
+                </a:solidFill>
+                <a:latin typeface="Calibri"/>
+                <a:hlinkClick r:id="rId18"/>
+              </a:rPr>
+              <a:t>statistiques.developpement-durable.gouv.fr</a:t>
+            </a:r>
+          </a:p>
+          <a:p>
+            <a:pPr>
+              <a:lnSpc>
+                <a:spcPct val="100000"/>
+              </a:lnSpc>
+              <a:spcAft>
+                <a:spcPts val="600"/>
+              </a:spcAft>
+            </a:pPr>
+            <a:r>
+              <a:rPr sz="1100" b="1">
+                <a:solidFill>
+                  <a:srgbClr val="37474F"/>
+                </a:solidFill>
+                <a:latin typeface="Calibri"/>
+              </a:rPr>
+              <a:t>Donnees climatiques (DJU, zone H1) </a:t>
+            </a:r>
+          </a:p>
+          <a:p>
+            <a:pPr>
+              <a:lnSpc>
+                <a:spcPct val="100000"/>
+              </a:lnSpc>
+              <a:spcAft>
+                <a:spcPts val="600"/>
+              </a:spcAft>
+            </a:pPr>
+            <a:r>
+              <a:rPr sz="1050">
+                <a:solidFill>
+                  <a:srgbClr val="1565C0"/>
+                </a:solidFill>
+                <a:latin typeface="Calibri"/>
+                <a:hlinkClick r:id="rId19"/>
+              </a:rPr>
+              <a:t>meteofrance.com</a:t>
+            </a:r>
+          </a:p>
+        </p:txBody>
+      </p:sp>
+    </p:spTree>
+  </p:cSld>
+  <p:clrMapOvr>
+    <a:masterClrMapping/>
+  </p:clrMapOvr>
+</p:sld>
+</file>
+
 <file path=ppt/slides/slide3.xml><?xml version="1.0" encoding="utf-8"?>
 <p:sld xmlns:a="http://schemas.openxmlformats.org/drawingml/2006/main" xmlns:p="http://schemas.openxmlformats.org/presentationml/2006/main" xmlns:r="http://schemas.openxmlformats.org/officeDocument/2006/relationships">
   <p:cSld>

</xml_diff>

<commit_message>
Recentre l'annexe sources sur Pleiades (outil reel de l'etude)
Remplace la longue liste de sites par une page honnete :
- Carte principale Pleiades (IZUBA energies) : modelisation, deperditions,
  DPE, simulation des gains, dimensionnement, couts
- Sources complementaires reduites : France Renov', ASDER, Legifrance, ADEME

https://claude.ai/code/session_01R4E5satKyZK8NHDSVCDJDk
</commit_message>
<xml_diff>
--- a/Soutenance_Renovation_Saint-Jean-de-Chevelu.pptx
+++ b/Soutenance_Renovation_Saint-Jean-de-Chevelu.pptx
@@ -2150,7 +2150,7 @@
           <a:lstStyle/>
           <a:p>
             <a:r>
-              <a:t>En annexe, j'ai regroupe toutes mes sources : a gauche les aides et le financement - France Renov', MaPrimeRenov', le simulateur officiel, l'Anah, l'eco-PTZ et l'ASDER qui est l'agence locale de l'energie en Savoie. Au centre, les fournisseurs et marques des materiaux et equipements que j'ai retenus. A droite, les sources techniques et reglementaires : l'ADEME, la methode 3CL du DPE, Legifrance pour la reglementation, le geoportail de l'urbanisme, les statistiques de prix de l'energie et Meteo-France pour les donnees climatiques. Je me tiens a votre disposition si vous souhaitez des precisions sur l'une de ces sources.</a:t>
+              <a:t>Pour la transparence : l'essentiel de l'etude - la modelisation, le bilan des deperditions, le calcul du DPE, la simulation des gains et le dimensionnement - a ete realise avec le logiciel Pleiades, d'IZUBA energies, qui fournit aussi les estimations de couts. En complement, je me suis appuye sur France Renov' et son simulateur pour les aides, l'ASDER comme conseil local en Savoie, Legifrance pour la reglementation, les documentations des fabricants pour les produits, et l'ADEME comme reference energie-climat. Je peux detailler n'importe lequel de ces points si vous le souhaitez.</a:t>
             </a:r>
           </a:p>
         </p:txBody>
@@ -27001,7 +27001,7 @@
                 </a:solidFill>
                 <a:latin typeface="Calibri"/>
               </a:rPr>
-              <a:t>References &amp; sources</a:t>
+              <a:t>Outils &amp; sources</a:t>
             </a:r>
           </a:p>
         </p:txBody>
@@ -27043,7 +27043,7 @@
                 </a:solidFill>
                 <a:latin typeface="Calibri"/>
               </a:rPr>
-              <a:t>Annexe - aides, fournisseurs et donnees techniques</a:t>
+              <a:t>Etude realisee principalement avec le logiciel Pleiades</a:t>
             </a:r>
           </a:p>
         </p:txBody>
@@ -27184,8 +27184,8 @@
         </p:nvSpPr>
         <p:spPr>
           <a:xfrm>
-            <a:off x="548640" y="1508760"/>
-            <a:ext cx="3611880" cy="4709160"/>
+            <a:off x="640080" y="1554480"/>
+            <a:ext cx="6035040" cy="4480560"/>
           </a:xfrm>
           <a:prstGeom prst="roundRect">
             <a:avLst/>
@@ -27230,8 +27230,8 @@
         </p:nvSpPr>
         <p:spPr>
           <a:xfrm>
-            <a:off x="548640" y="1508760"/>
-            <a:ext cx="3611880" cy="502920"/>
+            <a:off x="640080" y="1554480"/>
+            <a:ext cx="6035040" cy="868680"/>
           </a:xfrm>
           <a:prstGeom prst="roundRect">
             <a:avLst/>
@@ -27274,8 +27274,8 @@
         </p:nvSpPr>
         <p:spPr>
           <a:xfrm>
-            <a:off x="548640" y="1508760"/>
-            <a:ext cx="3611880" cy="502920"/>
+            <a:off x="868680" y="1627632"/>
+            <a:ext cx="5577840" cy="777240"/>
           </a:xfrm>
           <a:prstGeom prst="rect">
             <a:avLst/>
@@ -27283,12 +27283,73 @@
           <a:noFill/>
         </p:spPr>
         <p:txBody>
-          <a:bodyPr wrap="square" anchor="ctr" lIns="25400" rIns="25400" tIns="25400" bIns="25400">
+          <a:bodyPr wrap="square" anchor="t" lIns="25400" rIns="25400" tIns="25400" bIns="25400">
             <a:spAutoFit/>
           </a:bodyPr>
           <a:lstStyle/>
           <a:p>
-            <a:pPr algn="ctr">
+            <a:pPr algn="l">
+              <a:lnSpc>
+                <a:spcPct val="105000"/>
+              </a:lnSpc>
+              <a:spcAft>
+                <a:spcPts val="400"/>
+              </a:spcAft>
+            </a:pPr>
+            <a:r>
+              <a:rPr sz="2200" b="1" i="0">
+                <a:solidFill>
+                  <a:srgbClr val="FFFFFF"/>
+                </a:solidFill>
+                <a:latin typeface="Calibri"/>
+              </a:rPr>
+              <a:t>Pleiades</a:t>
+            </a:r>
+          </a:p>
+          <a:p>
+            <a:pPr algn="l">
+              <a:lnSpc>
+                <a:spcPct val="105000"/>
+              </a:lnSpc>
+              <a:spcAft>
+                <a:spcPts val="400"/>
+              </a:spcAft>
+            </a:pPr>
+            <a:r>
+              <a:rPr sz="1200" b="0" i="0">
+                <a:solidFill>
+                  <a:srgbClr val="C8E6C9"/>
+                </a:solidFill>
+                <a:latin typeface="Calibri"/>
+              </a:rPr>
+              <a:t>Logiciel de simulation thermique du batiment - IZUBA energies</a:t>
+            </a:r>
+          </a:p>
+        </p:txBody>
+      </p:sp>
+      <p:sp>
+        <p:nvSpPr>
+          <p:cNvPr id="12" name="TextBox 11"/>
+          <p:cNvSpPr txBox="1"/>
+          <p:nvPr/>
+        </p:nvSpPr>
+        <p:spPr>
+          <a:xfrm>
+            <a:off x="914400" y="2606040"/>
+            <a:ext cx="5486400" cy="365760"/>
+          </a:xfrm>
+          <a:prstGeom prst="rect">
+            <a:avLst/>
+          </a:prstGeom>
+          <a:noFill/>
+        </p:spPr>
+        <p:txBody>
+          <a:bodyPr wrap="square" anchor="t" lIns="25400" rIns="25400" tIns="25400" bIns="25400">
+            <a:spAutoFit/>
+          </a:bodyPr>
+          <a:lstStyle/>
+          <a:p>
+            <a:pPr algn="l">
               <a:lnSpc>
                 <a:spcPct val="100000"/>
               </a:lnSpc>
@@ -27297,27 +27358,27 @@
               </a:spcAft>
             </a:pPr>
             <a:r>
-              <a:rPr sz="1400" b="1" i="0">
-                <a:solidFill>
-                  <a:srgbClr val="FFFFFF"/>
-                </a:solidFill>
-                <a:latin typeface="Calibri"/>
-              </a:rPr>
-              <a:t>Aides &amp; financement</a:t>
-            </a:r>
-          </a:p>
-        </p:txBody>
-      </p:sp>
-      <p:sp>
-        <p:nvSpPr>
-          <p:cNvPr id="12" name="TextBox 11"/>
+              <a:rPr sz="1300" b="1" i="0">
+                <a:solidFill>
+                  <a:srgbClr val="37474F"/>
+                </a:solidFill>
+                <a:latin typeface="Calibri"/>
+              </a:rPr>
+              <a:t>Tout le travail technique et chiffre repose sur Pleiades :</a:t>
+            </a:r>
+          </a:p>
+        </p:txBody>
+      </p:sp>
+      <p:sp>
+        <p:nvSpPr>
+          <p:cNvPr id="13" name="TextBox 12"/>
           <p:cNvSpPr txBox="1"/>
           <p:nvPr/>
         </p:nvSpPr>
         <p:spPr>
           <a:xfrm>
-            <a:off x="713232" y="2148840"/>
-            <a:ext cx="3300984" cy="3931920"/>
+            <a:off x="914400" y="3063240"/>
+            <a:ext cx="5577840" cy="2834640"/>
           </a:xfrm>
           <a:prstGeom prst="rect">
             <a:avLst/>
@@ -27332,260 +27393,192 @@
           <a:p>
             <a:pPr>
               <a:lnSpc>
-                <a:spcPct val="100000"/>
+                <a:spcPct val="105000"/>
               </a:lnSpc>
               <a:spcAft>
-                <a:spcPts val="600"/>
+                <a:spcPts val="1000"/>
               </a:spcAft>
             </a:pPr>
             <a:r>
-              <a:rPr sz="1100" b="1">
+              <a:rPr sz="1350" b="1">
+                <a:solidFill>
+                  <a:srgbClr val="2E7D32"/>
+                </a:solidFill>
+                <a:latin typeface="Calibri"/>
+              </a:rPr>
+              <a:t>●  </a:t>
+            </a:r>
+            <a:r>
+              <a:rPr sz="1350">
                 <a:solidFill>
                   <a:srgbClr val="37474F"/>
                 </a:solidFill>
                 <a:latin typeface="Calibri"/>
               </a:rPr>
-              <a:t>France Renov' (service public) </a:t>
+              <a:t>Modelisation du batiment et de son enveloppe</a:t>
             </a:r>
           </a:p>
           <a:p>
             <a:pPr>
               <a:lnSpc>
-                <a:spcPct val="100000"/>
+                <a:spcPct val="105000"/>
               </a:lnSpc>
               <a:spcAft>
-                <a:spcPts val="600"/>
+                <a:spcPts val="1000"/>
               </a:spcAft>
             </a:pPr>
             <a:r>
-              <a:rPr sz="1050">
-                <a:solidFill>
-                  <a:srgbClr val="1565C0"/>
-                </a:solidFill>
-                <a:latin typeface="Calibri"/>
-                <a:hlinkClick r:id="rId2"/>
-              </a:rPr>
-              <a:t>france-renov.gouv.fr</a:t>
+              <a:rPr sz="1350" b="1">
+                <a:solidFill>
+                  <a:srgbClr val="2E7D32"/>
+                </a:solidFill>
+                <a:latin typeface="Calibri"/>
+              </a:rPr>
+              <a:t>●  </a:t>
+            </a:r>
+            <a:r>
+              <a:rPr sz="1350">
+                <a:solidFill>
+                  <a:srgbClr val="37474F"/>
+                </a:solidFill>
+                <a:latin typeface="Calibri"/>
+              </a:rPr>
+              <a:t>Bilan des deperditions &amp; coefficient Ubat</a:t>
             </a:r>
           </a:p>
           <a:p>
             <a:pPr>
               <a:lnSpc>
-                <a:spcPct val="100000"/>
+                <a:spcPct val="105000"/>
               </a:lnSpc>
               <a:spcAft>
-                <a:spcPts val="600"/>
+                <a:spcPts val="1000"/>
               </a:spcAft>
             </a:pPr>
             <a:r>
-              <a:rPr sz="1100" b="1">
+              <a:rPr sz="1350" b="1">
+                <a:solidFill>
+                  <a:srgbClr val="2E7D32"/>
+                </a:solidFill>
+                <a:latin typeface="Calibri"/>
+              </a:rPr>
+              <a:t>●  </a:t>
+            </a:r>
+            <a:r>
+              <a:rPr sz="1350">
                 <a:solidFill>
                   <a:srgbClr val="37474F"/>
                 </a:solidFill>
                 <a:latin typeface="Calibri"/>
               </a:rPr>
-              <a:t>MaPrimeRenov' </a:t>
+              <a:t>Calcul du DPE (energie primaire, CO2, etiquettes)</a:t>
             </a:r>
           </a:p>
           <a:p>
             <a:pPr>
               <a:lnSpc>
-                <a:spcPct val="100000"/>
+                <a:spcPct val="105000"/>
               </a:lnSpc>
               <a:spcAft>
-                <a:spcPts val="600"/>
+                <a:spcPts val="1000"/>
               </a:spcAft>
             </a:pPr>
             <a:r>
-              <a:rPr sz="1050">
-                <a:solidFill>
-                  <a:srgbClr val="1565C0"/>
-                </a:solidFill>
-                <a:latin typeface="Calibri"/>
-                <a:hlinkClick r:id="rId3"/>
-              </a:rPr>
-              <a:t>maprimerenov.gouv.fr</a:t>
+              <a:rPr sz="1350" b="1">
+                <a:solidFill>
+                  <a:srgbClr val="2E7D32"/>
+                </a:solidFill>
+                <a:latin typeface="Calibri"/>
+              </a:rPr>
+              <a:t>●  </a:t>
+            </a:r>
+            <a:r>
+              <a:rPr sz="1350">
+                <a:solidFill>
+                  <a:srgbClr val="37474F"/>
+                </a:solidFill>
+                <a:latin typeface="Calibri"/>
+              </a:rPr>
+              <a:t>Simulation des gains energetiques apres travaux</a:t>
             </a:r>
           </a:p>
           <a:p>
             <a:pPr>
               <a:lnSpc>
-                <a:spcPct val="100000"/>
+                <a:spcPct val="105000"/>
               </a:lnSpc>
               <a:spcAft>
-                <a:spcPts val="600"/>
+                <a:spcPts val="1000"/>
               </a:spcAft>
             </a:pPr>
             <a:r>
-              <a:rPr sz="1100" b="1">
+              <a:rPr sz="1350" b="1">
+                <a:solidFill>
+                  <a:srgbClr val="2E7D32"/>
+                </a:solidFill>
+                <a:latin typeface="Calibri"/>
+              </a:rPr>
+              <a:t>●  </a:t>
+            </a:r>
+            <a:r>
+              <a:rPr sz="1350">
                 <a:solidFill>
                   <a:srgbClr val="37474F"/>
                 </a:solidFill>
                 <a:latin typeface="Calibri"/>
               </a:rPr>
-              <a:t>Simulateur d'aides </a:t>
+              <a:t>Dimensionnement des equipements (chauffage, VMC)</a:t>
             </a:r>
           </a:p>
           <a:p>
             <a:pPr>
               <a:lnSpc>
-                <a:spcPct val="100000"/>
+                <a:spcPct val="105000"/>
               </a:lnSpc>
               <a:spcAft>
-                <a:spcPts val="600"/>
+                <a:spcPts val="1000"/>
               </a:spcAft>
             </a:pPr>
             <a:r>
-              <a:rPr sz="1050">
-                <a:solidFill>
-                  <a:srgbClr val="1565C0"/>
-                </a:solidFill>
-                <a:latin typeface="Calibri"/>
-                <a:hlinkClick r:id="rId4"/>
-              </a:rPr>
-              <a:t>mesaidesreno.gouv.fr</a:t>
-            </a:r>
-          </a:p>
-          <a:p>
-            <a:pPr>
-              <a:lnSpc>
-                <a:spcPct val="100000"/>
-              </a:lnSpc>
-              <a:spcAft>
-                <a:spcPts val="600"/>
-              </a:spcAft>
-            </a:pPr>
-            <a:r>
-              <a:rPr sz="1100" b="1">
+              <a:rPr sz="1350" b="1">
+                <a:solidFill>
+                  <a:srgbClr val="2E7D32"/>
+                </a:solidFill>
+                <a:latin typeface="Calibri"/>
+              </a:rPr>
+              <a:t>●  </a:t>
+            </a:r>
+            <a:r>
+              <a:rPr sz="1350">
                 <a:solidFill>
                   <a:srgbClr val="37474F"/>
                 </a:solidFill>
                 <a:latin typeface="Calibri"/>
               </a:rPr>
-              <a:t>Anah </a:t>
-            </a:r>
-          </a:p>
-          <a:p>
-            <a:pPr>
-              <a:lnSpc>
-                <a:spcPct val="100000"/>
-              </a:lnSpc>
-              <a:spcAft>
-                <a:spcPts val="600"/>
-              </a:spcAft>
-            </a:pPr>
-            <a:r>
-              <a:rPr sz="1050">
-                <a:solidFill>
-                  <a:srgbClr val="1565C0"/>
-                </a:solidFill>
-                <a:latin typeface="Calibri"/>
-                <a:hlinkClick r:id="rId5"/>
-              </a:rPr>
-              <a:t>anah.gouv.fr</a:t>
-            </a:r>
-          </a:p>
-          <a:p>
-            <a:pPr>
-              <a:lnSpc>
-                <a:spcPct val="100000"/>
-              </a:lnSpc>
-              <a:spcAft>
-                <a:spcPts val="600"/>
-              </a:spcAft>
-            </a:pPr>
-            <a:r>
-              <a:rPr sz="1100" b="1">
-                <a:solidFill>
-                  <a:srgbClr val="37474F"/>
-                </a:solidFill>
-                <a:latin typeface="Calibri"/>
-              </a:rPr>
-              <a:t>Eco-PTZ &amp; CEE </a:t>
-            </a:r>
-          </a:p>
-          <a:p>
-            <a:pPr>
-              <a:lnSpc>
-                <a:spcPct val="100000"/>
-              </a:lnSpc>
-              <a:spcAft>
-                <a:spcPts val="600"/>
-              </a:spcAft>
-            </a:pPr>
-            <a:r>
-              <a:rPr sz="1050">
-                <a:solidFill>
-                  <a:srgbClr val="1565C0"/>
-                </a:solidFill>
-                <a:latin typeface="Calibri"/>
-                <a:hlinkClick r:id="rId6"/>
-              </a:rPr>
-              <a:t>service-public.fr</a:t>
-            </a:r>
-          </a:p>
-          <a:p>
-            <a:pPr>
-              <a:lnSpc>
-                <a:spcPct val="100000"/>
-              </a:lnSpc>
-              <a:spcAft>
-                <a:spcPts val="600"/>
-              </a:spcAft>
-            </a:pPr>
-            <a:r>
-              <a:rPr sz="1100" b="1">
-                <a:solidFill>
-                  <a:srgbClr val="37474F"/>
-                </a:solidFill>
-                <a:latin typeface="Calibri"/>
-              </a:rPr>
-              <a:t>ASDER - espace conseil (Savoie) </a:t>
-            </a:r>
-          </a:p>
-          <a:p>
-            <a:pPr>
-              <a:lnSpc>
-                <a:spcPct val="100000"/>
-              </a:lnSpc>
-              <a:spcAft>
-                <a:spcPts val="600"/>
-              </a:spcAft>
-            </a:pPr>
-            <a:r>
-              <a:rPr sz="1050">
-                <a:solidFill>
-                  <a:srgbClr val="1565C0"/>
-                </a:solidFill>
-                <a:latin typeface="Calibri"/>
-                <a:hlinkClick r:id="rId7"/>
-              </a:rPr>
-              <a:t>asder.asso.fr</a:t>
-            </a:r>
-          </a:p>
-        </p:txBody>
-      </p:sp>
-      <p:sp>
-        <p:nvSpPr>
-          <p:cNvPr id="13" name="Rounded Rectangle 12"/>
+              <a:t>Estimation des couts de travaux et analyse economique</a:t>
+            </a:r>
+          </a:p>
+        </p:txBody>
+      </p:sp>
+      <p:sp>
+        <p:nvSpPr>
+          <p:cNvPr id="14" name="Rounded Rectangle 13"/>
           <p:cNvSpPr/>
           <p:nvPr/>
         </p:nvSpPr>
         <p:spPr>
           <a:xfrm>
-            <a:off x="4297680" y="1508760"/>
-            <a:ext cx="3611880" cy="4709160"/>
+            <a:off x="6858000" y="1554480"/>
+            <a:ext cx="4663440" cy="4480560"/>
           </a:xfrm>
           <a:prstGeom prst="roundRect">
             <a:avLst/>
           </a:prstGeom>
           <a:solidFill>
-            <a:srgbClr val="FFFFFF"/>
+            <a:srgbClr val="E8F5E9"/>
           </a:solidFill>
-          <a:ln w="12700">
-            <a:solidFill>
-              <a:srgbClr val="90A4AE"/>
-            </a:solidFill>
+          <a:ln>
+            <a:noFill/>
           </a:ln>
           <a:effectLst/>
         </p:spPr>
@@ -27613,58 +27606,14 @@
       </p:sp>
       <p:sp>
         <p:nvSpPr>
-          <p:cNvPr id="14" name="Rounded Rectangle 13"/>
-          <p:cNvSpPr/>
-          <p:nvPr/>
-        </p:nvSpPr>
-        <p:spPr>
-          <a:xfrm>
-            <a:off x="4297680" y="1508760"/>
-            <a:ext cx="3611880" cy="502920"/>
-          </a:xfrm>
-          <a:prstGeom prst="roundRect">
-            <a:avLst/>
-          </a:prstGeom>
-          <a:solidFill>
-            <a:srgbClr val="1565C0"/>
-          </a:solidFill>
-          <a:ln>
-            <a:noFill/>
-          </a:ln>
-          <a:effectLst/>
-        </p:spPr>
-        <p:style>
-          <a:lnRef idx="1">
-            <a:schemeClr val="accent1"/>
-          </a:lnRef>
-          <a:fillRef idx="3">
-            <a:schemeClr val="accent1"/>
-          </a:fillRef>
-          <a:effectRef idx="2">
-            <a:schemeClr val="accent1"/>
-          </a:effectRef>
-          <a:fontRef idx="minor">
-            <a:schemeClr val="lt1"/>
-          </a:fontRef>
-        </p:style>
-        <p:txBody>
-          <a:bodyPr rtlCol="0" anchor="ctr"/>
-          <a:lstStyle/>
-          <a:p>
-            <a:pPr algn="ctr"/>
-          </a:p>
-        </p:txBody>
-      </p:sp>
-      <p:sp>
-        <p:nvSpPr>
           <p:cNvPr id="15" name="TextBox 14"/>
           <p:cNvSpPr txBox="1"/>
           <p:nvPr/>
         </p:nvSpPr>
         <p:spPr>
           <a:xfrm>
-            <a:off x="4297680" y="1508760"/>
-            <a:ext cx="3611880" cy="502920"/>
+            <a:off x="7086600" y="1691640"/>
+            <a:ext cx="4297680" cy="365760"/>
           </a:xfrm>
           <a:prstGeom prst="rect">
             <a:avLst/>
@@ -27672,12 +27621,12 @@
           <a:noFill/>
         </p:spPr>
         <p:txBody>
-          <a:bodyPr wrap="square" anchor="ctr" lIns="25400" rIns="25400" tIns="25400" bIns="25400">
+          <a:bodyPr wrap="square" anchor="t" lIns="25400" rIns="25400" tIns="25400" bIns="25400">
             <a:spAutoFit/>
           </a:bodyPr>
           <a:lstStyle/>
           <a:p>
-            <a:pPr algn="ctr">
+            <a:pPr algn="l">
               <a:lnSpc>
                 <a:spcPct val="100000"/>
               </a:lnSpc>
@@ -27686,13 +27635,13 @@
               </a:spcAft>
             </a:pPr>
             <a:r>
-              <a:rPr sz="1400" b="1" i="0">
-                <a:solidFill>
-                  <a:srgbClr val="FFFFFF"/>
-                </a:solidFill>
-                <a:latin typeface="Calibri"/>
-              </a:rPr>
-              <a:t>Materiaux &amp; equipements</a:t>
+              <a:rPr sz="1500" b="1" i="0">
+                <a:solidFill>
+                  <a:srgbClr val="1B5E20"/>
+                </a:solidFill>
+                <a:latin typeface="Calibri"/>
+              </a:rPr>
+              <a:t>Sources complementaires</a:t>
             </a:r>
           </a:p>
         </p:txBody>
@@ -27705,8 +27654,8 @@
         </p:nvSpPr>
         <p:spPr>
           <a:xfrm>
-            <a:off x="4462272" y="2148840"/>
-            <a:ext cx="3300984" cy="3931920"/>
+            <a:off x="7086600" y="2240280"/>
+            <a:ext cx="4297680" cy="292608"/>
           </a:xfrm>
           <a:prstGeom prst="rect">
             <a:avLst/>
@@ -27714,359 +27663,12 @@
           <a:noFill/>
         </p:spPr>
         <p:txBody>
-          <a:bodyPr wrap="square">
+          <a:bodyPr wrap="square" anchor="t" lIns="25400" rIns="25400" tIns="25400" bIns="25400">
             <a:spAutoFit/>
           </a:bodyPr>
           <a:lstStyle/>
           <a:p>
-            <a:pPr>
-              <a:lnSpc>
-                <a:spcPct val="100000"/>
-              </a:lnSpc>
-              <a:spcAft>
-                <a:spcPts val="600"/>
-              </a:spcAft>
-            </a:pPr>
-            <a:r>
-              <a:rPr sz="1100" b="1">
-                <a:solidFill>
-                  <a:srgbClr val="37474F"/>
-                </a:solidFill>
-                <a:latin typeface="Calibri"/>
-              </a:rPr>
-              <a:t>Laine de bois (ITE) </a:t>
-            </a:r>
-          </a:p>
-          <a:p>
-            <a:pPr>
-              <a:lnSpc>
-                <a:spcPct val="100000"/>
-              </a:lnSpc>
-              <a:spcAft>
-                <a:spcPts val="600"/>
-              </a:spcAft>
-            </a:pPr>
-            <a:r>
-              <a:rPr sz="1050">
-                <a:solidFill>
-                  <a:srgbClr val="1565C0"/>
-                </a:solidFill>
-                <a:latin typeface="Calibri"/>
-                <a:hlinkClick r:id="rId8"/>
-              </a:rPr>
-              <a:t>steico.com  -  soprema.fr</a:t>
-            </a:r>
-          </a:p>
-          <a:p>
-            <a:pPr>
-              <a:lnSpc>
-                <a:spcPct val="100000"/>
-              </a:lnSpc>
-              <a:spcAft>
-                <a:spcPts val="600"/>
-              </a:spcAft>
-            </a:pPr>
-            <a:r>
-              <a:rPr sz="1100" b="1">
-                <a:solidFill>
-                  <a:srgbClr val="37474F"/>
-                </a:solidFill>
-                <a:latin typeface="Calibri"/>
-              </a:rPr>
-              <a:t>Ouate de cellulose </a:t>
-            </a:r>
-          </a:p>
-          <a:p>
-            <a:pPr>
-              <a:lnSpc>
-                <a:spcPct val="100000"/>
-              </a:lnSpc>
-              <a:spcAft>
-                <a:spcPts val="600"/>
-              </a:spcAft>
-            </a:pPr>
-            <a:r>
-              <a:rPr sz="1050">
-                <a:solidFill>
-                  <a:srgbClr val="1565C0"/>
-                </a:solidFill>
-                <a:latin typeface="Calibri"/>
-                <a:hlinkClick r:id="rId9"/>
-              </a:rPr>
-              <a:t>ouateco.com  -  isocell.com</a:t>
-            </a:r>
-          </a:p>
-          <a:p>
-            <a:pPr>
-              <a:lnSpc>
-                <a:spcPct val="100000"/>
-              </a:lnSpc>
-              <a:spcAft>
-                <a:spcPts val="600"/>
-              </a:spcAft>
-            </a:pPr>
-            <a:r>
-              <a:rPr sz="1100" b="1">
-                <a:solidFill>
-                  <a:srgbClr val="37474F"/>
-                </a:solidFill>
-                <a:latin typeface="Calibri"/>
-              </a:rPr>
-              <a:t>VMC hygro B </a:t>
-            </a:r>
-          </a:p>
-          <a:p>
-            <a:pPr>
-              <a:lnSpc>
-                <a:spcPct val="100000"/>
-              </a:lnSpc>
-              <a:spcAft>
-                <a:spcPts val="600"/>
-              </a:spcAft>
-            </a:pPr>
-            <a:r>
-              <a:rPr sz="1050">
-                <a:solidFill>
-                  <a:srgbClr val="1565C0"/>
-                </a:solidFill>
-                <a:latin typeface="Calibri"/>
-                <a:hlinkClick r:id="rId10"/>
-              </a:rPr>
-              <a:t>aldes.fr  -  atlantic.fr</a:t>
-            </a:r>
-          </a:p>
-          <a:p>
-            <a:pPr>
-              <a:lnSpc>
-                <a:spcPct val="100000"/>
-              </a:lnSpc>
-              <a:spcAft>
-                <a:spcPts val="600"/>
-              </a:spcAft>
-            </a:pPr>
-            <a:r>
-              <a:rPr sz="1100" b="1">
-                <a:solidFill>
-                  <a:srgbClr val="37474F"/>
-                </a:solidFill>
-                <a:latin typeface="Calibri"/>
-              </a:rPr>
-              <a:t>Chauffe-eau thermodynamique </a:t>
-            </a:r>
-          </a:p>
-          <a:p>
-            <a:pPr>
-              <a:lnSpc>
-                <a:spcPct val="100000"/>
-              </a:lnSpc>
-              <a:spcAft>
-                <a:spcPts val="600"/>
-              </a:spcAft>
-            </a:pPr>
-            <a:r>
-              <a:rPr sz="1050">
-                <a:solidFill>
-                  <a:srgbClr val="1565C0"/>
-                </a:solidFill>
-                <a:latin typeface="Calibri"/>
-                <a:hlinkClick r:id="rId11"/>
-              </a:rPr>
-              <a:t>atlantic.fr  -  thermor.fr</a:t>
-            </a:r>
-          </a:p>
-          <a:p>
-            <a:pPr>
-              <a:lnSpc>
-                <a:spcPct val="100000"/>
-              </a:lnSpc>
-              <a:spcAft>
-                <a:spcPts val="600"/>
-              </a:spcAft>
-            </a:pPr>
-            <a:r>
-              <a:rPr sz="1100" b="1">
-                <a:solidFill>
-                  <a:srgbClr val="37474F"/>
-                </a:solidFill>
-                <a:latin typeface="Calibri"/>
-              </a:rPr>
-              <a:t>Chaudiere a granules </a:t>
-            </a:r>
-          </a:p>
-          <a:p>
-            <a:pPr>
-              <a:lnSpc>
-                <a:spcPct val="100000"/>
-              </a:lnSpc>
-              <a:spcAft>
-                <a:spcPts val="600"/>
-              </a:spcAft>
-            </a:pPr>
-            <a:r>
-              <a:rPr sz="1050">
-                <a:solidFill>
-                  <a:srgbClr val="1565C0"/>
-                </a:solidFill>
-                <a:latin typeface="Calibri"/>
-                <a:hlinkClick r:id="rId12"/>
-              </a:rPr>
-              <a:t>oekofen.com  -  hargassner.com</a:t>
-            </a:r>
-          </a:p>
-          <a:p>
-            <a:pPr>
-              <a:lnSpc>
-                <a:spcPct val="100000"/>
-              </a:lnSpc>
-              <a:spcAft>
-                <a:spcPts val="600"/>
-              </a:spcAft>
-            </a:pPr>
-            <a:r>
-              <a:rPr sz="1100" b="1">
-                <a:solidFill>
-                  <a:srgbClr val="37474F"/>
-                </a:solidFill>
-                <a:latin typeface="Calibri"/>
-              </a:rPr>
-              <a:t>Enduit / finition ITE </a:t>
-            </a:r>
-          </a:p>
-          <a:p>
-            <a:pPr>
-              <a:lnSpc>
-                <a:spcPct val="100000"/>
-              </a:lnSpc>
-              <a:spcAft>
-                <a:spcPts val="600"/>
-              </a:spcAft>
-            </a:pPr>
-            <a:r>
-              <a:rPr sz="1050">
-                <a:solidFill>
-                  <a:srgbClr val="1565C0"/>
-                </a:solidFill>
-                <a:latin typeface="Calibri"/>
-                <a:hlinkClick r:id="rId13"/>
-              </a:rPr>
-              <a:t>fr.weber  -  parexlanko.com</a:t>
-            </a:r>
-          </a:p>
-        </p:txBody>
-      </p:sp>
-      <p:sp>
-        <p:nvSpPr>
-          <p:cNvPr id="17" name="Rounded Rectangle 16"/>
-          <p:cNvSpPr/>
-          <p:nvPr/>
-        </p:nvSpPr>
-        <p:spPr>
-          <a:xfrm>
-            <a:off x="8046720" y="1508760"/>
-            <a:ext cx="3611880" cy="4709160"/>
-          </a:xfrm>
-          <a:prstGeom prst="roundRect">
-            <a:avLst/>
-          </a:prstGeom>
-          <a:solidFill>
-            <a:srgbClr val="FFFFFF"/>
-          </a:solidFill>
-          <a:ln w="12700">
-            <a:solidFill>
-              <a:srgbClr val="90A4AE"/>
-            </a:solidFill>
-          </a:ln>
-          <a:effectLst/>
-        </p:spPr>
-        <p:style>
-          <a:lnRef idx="1">
-            <a:schemeClr val="accent1"/>
-          </a:lnRef>
-          <a:fillRef idx="3">
-            <a:schemeClr val="accent1"/>
-          </a:fillRef>
-          <a:effectRef idx="2">
-            <a:schemeClr val="accent1"/>
-          </a:effectRef>
-          <a:fontRef idx="minor">
-            <a:schemeClr val="lt1"/>
-          </a:fontRef>
-        </p:style>
-        <p:txBody>
-          <a:bodyPr rtlCol="0" anchor="ctr"/>
-          <a:lstStyle/>
-          <a:p>
-            <a:pPr algn="ctr"/>
-          </a:p>
-        </p:txBody>
-      </p:sp>
-      <p:sp>
-        <p:nvSpPr>
-          <p:cNvPr id="18" name="Rounded Rectangle 17"/>
-          <p:cNvSpPr/>
-          <p:nvPr/>
-        </p:nvSpPr>
-        <p:spPr>
-          <a:xfrm>
-            <a:off x="8046720" y="1508760"/>
-            <a:ext cx="3611880" cy="502920"/>
-          </a:xfrm>
-          <a:prstGeom prst="roundRect">
-            <a:avLst/>
-          </a:prstGeom>
-          <a:solidFill>
-            <a:srgbClr val="E65100"/>
-          </a:solidFill>
-          <a:ln>
-            <a:noFill/>
-          </a:ln>
-          <a:effectLst/>
-        </p:spPr>
-        <p:style>
-          <a:lnRef idx="1">
-            <a:schemeClr val="accent1"/>
-          </a:lnRef>
-          <a:fillRef idx="3">
-            <a:schemeClr val="accent1"/>
-          </a:fillRef>
-          <a:effectRef idx="2">
-            <a:schemeClr val="accent1"/>
-          </a:effectRef>
-          <a:fontRef idx="minor">
-            <a:schemeClr val="lt1"/>
-          </a:fontRef>
-        </p:style>
-        <p:txBody>
-          <a:bodyPr rtlCol="0" anchor="ctr"/>
-          <a:lstStyle/>
-          <a:p>
-            <a:pPr algn="ctr"/>
-          </a:p>
-        </p:txBody>
-      </p:sp>
-      <p:sp>
-        <p:nvSpPr>
-          <p:cNvPr id="19" name="TextBox 18"/>
-          <p:cNvSpPr txBox="1"/>
-          <p:nvPr/>
-        </p:nvSpPr>
-        <p:spPr>
-          <a:xfrm>
-            <a:off x="8046720" y="1508760"/>
-            <a:ext cx="3611880" cy="502920"/>
-          </a:xfrm>
-          <a:prstGeom prst="rect">
-            <a:avLst/>
-          </a:prstGeom>
-          <a:noFill/>
-        </p:spPr>
-        <p:txBody>
-          <a:bodyPr wrap="square" anchor="ctr" lIns="25400" rIns="25400" tIns="25400" bIns="25400">
-            <a:spAutoFit/>
-          </a:bodyPr>
-          <a:lstStyle/>
-          <a:p>
-            <a:pPr algn="ctr">
+            <a:pPr algn="l">
               <a:lnSpc>
                 <a:spcPct val="100000"/>
               </a:lnSpc>
@@ -28075,27 +27677,27 @@
               </a:spcAft>
             </a:pPr>
             <a:r>
-              <a:rPr sz="1400" b="1" i="0">
-                <a:solidFill>
-                  <a:srgbClr val="FFFFFF"/>
-                </a:solidFill>
-                <a:latin typeface="Calibri"/>
-              </a:rPr>
-              <a:t>Donnees &amp; reglementation</a:t>
-            </a:r>
-          </a:p>
-        </p:txBody>
-      </p:sp>
-      <p:sp>
-        <p:nvSpPr>
-          <p:cNvPr id="20" name="TextBox 19"/>
+              <a:rPr sz="1250" b="1" i="0">
+                <a:solidFill>
+                  <a:srgbClr val="37474F"/>
+                </a:solidFill>
+                <a:latin typeface="Calibri"/>
+              </a:rPr>
+              <a:t>Aides &amp; simulateur (France Renov')</a:t>
+            </a:r>
+          </a:p>
+        </p:txBody>
+      </p:sp>
+      <p:sp>
+        <p:nvSpPr>
+          <p:cNvPr id="17" name="TextBox 16"/>
           <p:cNvSpPr txBox="1"/>
           <p:nvPr/>
         </p:nvSpPr>
         <p:spPr>
           <a:xfrm>
-            <a:off x="8211312" y="2148840"/>
-            <a:ext cx="3300984" cy="3931920"/>
+            <a:off x="7086600" y="2496312"/>
+            <a:ext cx="4297680" cy="274320"/>
           </a:xfrm>
           <a:prstGeom prst="rect">
             <a:avLst/>
@@ -28103,242 +27705,328 @@
           <a:noFill/>
         </p:spPr>
         <p:txBody>
-          <a:bodyPr wrap="square">
+          <a:bodyPr wrap="none">
             <a:spAutoFit/>
           </a:bodyPr>
           <a:lstStyle/>
           <a:p>
-            <a:pPr>
+            <a:r>
+              <a:rPr sz="1150">
+                <a:solidFill>
+                  <a:srgbClr val="1565C0"/>
+                </a:solidFill>
+                <a:latin typeface="Calibri"/>
+                <a:hlinkClick r:id="rId2"/>
+              </a:rPr>
+              <a:t>france-renov.gouv.fr</a:t>
+            </a:r>
+          </a:p>
+        </p:txBody>
+      </p:sp>
+      <p:sp>
+        <p:nvSpPr>
+          <p:cNvPr id="18" name="TextBox 17"/>
+          <p:cNvSpPr txBox="1"/>
+          <p:nvPr/>
+        </p:nvSpPr>
+        <p:spPr>
+          <a:xfrm>
+            <a:off x="7086600" y="2926080"/>
+            <a:ext cx="4297680" cy="292608"/>
+          </a:xfrm>
+          <a:prstGeom prst="rect">
+            <a:avLst/>
+          </a:prstGeom>
+          <a:noFill/>
+        </p:spPr>
+        <p:txBody>
+          <a:bodyPr wrap="square" anchor="t" lIns="25400" rIns="25400" tIns="25400" bIns="25400">
+            <a:spAutoFit/>
+          </a:bodyPr>
+          <a:lstStyle/>
+          <a:p>
+            <a:pPr algn="l">
               <a:lnSpc>
                 <a:spcPct val="100000"/>
               </a:lnSpc>
               <a:spcAft>
-                <a:spcPts val="600"/>
+                <a:spcPts val="400"/>
               </a:spcAft>
             </a:pPr>
             <a:r>
-              <a:rPr sz="1100" b="1">
+              <a:rPr sz="1250" b="1" i="0">
                 <a:solidFill>
                   <a:srgbClr val="37474F"/>
                 </a:solidFill>
                 <a:latin typeface="Calibri"/>
               </a:rPr>
-              <a:t>ADEME (energie / climat) </a:t>
-            </a:r>
-          </a:p>
-          <a:p>
-            <a:pPr>
+              <a:t>Conseil local energie (Savoie)</a:t>
+            </a:r>
+          </a:p>
+        </p:txBody>
+      </p:sp>
+      <p:sp>
+        <p:nvSpPr>
+          <p:cNvPr id="19" name="TextBox 18"/>
+          <p:cNvSpPr txBox="1"/>
+          <p:nvPr/>
+        </p:nvSpPr>
+        <p:spPr>
+          <a:xfrm>
+            <a:off x="7086600" y="3182112"/>
+            <a:ext cx="4297680" cy="274320"/>
+          </a:xfrm>
+          <a:prstGeom prst="rect">
+            <a:avLst/>
+          </a:prstGeom>
+          <a:noFill/>
+        </p:spPr>
+        <p:txBody>
+          <a:bodyPr wrap="none">
+            <a:spAutoFit/>
+          </a:bodyPr>
+          <a:lstStyle/>
+          <a:p>
+            <a:r>
+              <a:rPr sz="1150">
+                <a:solidFill>
+                  <a:srgbClr val="1565C0"/>
+                </a:solidFill>
+                <a:latin typeface="Calibri"/>
+                <a:hlinkClick r:id="rId3"/>
+              </a:rPr>
+              <a:t>asder.asso.fr</a:t>
+            </a:r>
+          </a:p>
+        </p:txBody>
+      </p:sp>
+      <p:sp>
+        <p:nvSpPr>
+          <p:cNvPr id="20" name="TextBox 19"/>
+          <p:cNvSpPr txBox="1"/>
+          <p:nvPr/>
+        </p:nvSpPr>
+        <p:spPr>
+          <a:xfrm>
+            <a:off x="7086600" y="3611880"/>
+            <a:ext cx="4297680" cy="292608"/>
+          </a:xfrm>
+          <a:prstGeom prst="rect">
+            <a:avLst/>
+          </a:prstGeom>
+          <a:noFill/>
+        </p:spPr>
+        <p:txBody>
+          <a:bodyPr wrap="square" anchor="t" lIns="25400" rIns="25400" tIns="25400" bIns="25400">
+            <a:spAutoFit/>
+          </a:bodyPr>
+          <a:lstStyle/>
+          <a:p>
+            <a:pPr algn="l">
               <a:lnSpc>
                 <a:spcPct val="100000"/>
               </a:lnSpc>
               <a:spcAft>
-                <a:spcPts val="600"/>
+                <a:spcPts val="400"/>
               </a:spcAft>
             </a:pPr>
             <a:r>
-              <a:rPr sz="1050">
+              <a:rPr sz="1250" b="1" i="0">
+                <a:solidFill>
+                  <a:srgbClr val="37474F"/>
+                </a:solidFill>
+                <a:latin typeface="Calibri"/>
+              </a:rPr>
+              <a:t>Reglementation (CCH, arretes DPE)</a:t>
+            </a:r>
+          </a:p>
+        </p:txBody>
+      </p:sp>
+      <p:sp>
+        <p:nvSpPr>
+          <p:cNvPr id="21" name="TextBox 20"/>
+          <p:cNvSpPr txBox="1"/>
+          <p:nvPr/>
+        </p:nvSpPr>
+        <p:spPr>
+          <a:xfrm>
+            <a:off x="7086600" y="3867912"/>
+            <a:ext cx="4297680" cy="274320"/>
+          </a:xfrm>
+          <a:prstGeom prst="rect">
+            <a:avLst/>
+          </a:prstGeom>
+          <a:noFill/>
+        </p:spPr>
+        <p:txBody>
+          <a:bodyPr wrap="none">
+            <a:spAutoFit/>
+          </a:bodyPr>
+          <a:lstStyle/>
+          <a:p>
+            <a:r>
+              <a:rPr sz="1150">
                 <a:solidFill>
                   <a:srgbClr val="1565C0"/>
                 </a:solidFill>
                 <a:latin typeface="Calibri"/>
-                <a:hlinkClick r:id="rId14"/>
-              </a:rPr>
-              <a:t>ademe.fr</a:t>
-            </a:r>
-          </a:p>
-          <a:p>
-            <a:pPr>
+                <a:hlinkClick r:id="rId4"/>
+              </a:rPr>
+              <a:t>legifrance.gouv.fr</a:t>
+            </a:r>
+          </a:p>
+        </p:txBody>
+      </p:sp>
+      <p:sp>
+        <p:nvSpPr>
+          <p:cNvPr id="22" name="TextBox 21"/>
+          <p:cNvSpPr txBox="1"/>
+          <p:nvPr/>
+        </p:nvSpPr>
+        <p:spPr>
+          <a:xfrm>
+            <a:off x="7086600" y="4297680"/>
+            <a:ext cx="4297680" cy="292608"/>
+          </a:xfrm>
+          <a:prstGeom prst="rect">
+            <a:avLst/>
+          </a:prstGeom>
+          <a:noFill/>
+        </p:spPr>
+        <p:txBody>
+          <a:bodyPr wrap="square" anchor="t" lIns="25400" rIns="25400" tIns="25400" bIns="25400">
+            <a:spAutoFit/>
+          </a:bodyPr>
+          <a:lstStyle/>
+          <a:p>
+            <a:pPr algn="l">
               <a:lnSpc>
                 <a:spcPct val="100000"/>
               </a:lnSpc>
               <a:spcAft>
-                <a:spcPts val="600"/>
+                <a:spcPts val="400"/>
               </a:spcAft>
             </a:pPr>
             <a:r>
-              <a:rPr sz="1100" b="1">
+              <a:rPr sz="1250" b="1" i="0">
                 <a:solidFill>
                   <a:srgbClr val="37474F"/>
                 </a:solidFill>
                 <a:latin typeface="Calibri"/>
               </a:rPr>
-              <a:t>DPE - methode 3CL &amp; observatoire </a:t>
-            </a:r>
-          </a:p>
-          <a:p>
-            <a:pPr>
+              <a:t>Donnees produits</a:t>
+            </a:r>
+          </a:p>
+        </p:txBody>
+      </p:sp>
+      <p:sp>
+        <p:nvSpPr>
+          <p:cNvPr id="23" name="TextBox 22"/>
+          <p:cNvSpPr txBox="1"/>
+          <p:nvPr/>
+        </p:nvSpPr>
+        <p:spPr>
+          <a:xfrm>
+            <a:off x="7086600" y="4553712"/>
+            <a:ext cx="4297680" cy="274320"/>
+          </a:xfrm>
+          <a:prstGeom prst="rect">
+            <a:avLst/>
+          </a:prstGeom>
+          <a:noFill/>
+        </p:spPr>
+        <p:txBody>
+          <a:bodyPr wrap="none">
+            <a:spAutoFit/>
+          </a:bodyPr>
+          <a:lstStyle/>
+          <a:p>
+            <a:r>
+              <a:rPr sz="1150">
+                <a:solidFill>
+                  <a:srgbClr val="1565C0"/>
+                </a:solidFill>
+                <a:latin typeface="Calibri"/>
+                <a:hlinkClick r:id="rId5"/>
+              </a:rPr>
+              <a:t>documentations techniques fabricants</a:t>
+            </a:r>
+          </a:p>
+        </p:txBody>
+      </p:sp>
+      <p:sp>
+        <p:nvSpPr>
+          <p:cNvPr id="24" name="TextBox 23"/>
+          <p:cNvSpPr txBox="1"/>
+          <p:nvPr/>
+        </p:nvSpPr>
+        <p:spPr>
+          <a:xfrm>
+            <a:off x="7086600" y="4983480"/>
+            <a:ext cx="4297680" cy="292608"/>
+          </a:xfrm>
+          <a:prstGeom prst="rect">
+            <a:avLst/>
+          </a:prstGeom>
+          <a:noFill/>
+        </p:spPr>
+        <p:txBody>
+          <a:bodyPr wrap="square" anchor="t" lIns="25400" rIns="25400" tIns="25400" bIns="25400">
+            <a:spAutoFit/>
+          </a:bodyPr>
+          <a:lstStyle/>
+          <a:p>
+            <a:pPr algn="l">
               <a:lnSpc>
                 <a:spcPct val="100000"/>
               </a:lnSpc>
               <a:spcAft>
-                <a:spcPts val="600"/>
+                <a:spcPts val="400"/>
               </a:spcAft>
             </a:pPr>
             <a:r>
-              <a:rPr sz="1050">
+              <a:rPr sz="1250" b="1" i="0">
+                <a:solidFill>
+                  <a:srgbClr val="37474F"/>
+                </a:solidFill>
+                <a:latin typeface="Calibri"/>
+              </a:rPr>
+              <a:t>Reference energie / climat</a:t>
+            </a:r>
+          </a:p>
+        </p:txBody>
+      </p:sp>
+      <p:sp>
+        <p:nvSpPr>
+          <p:cNvPr id="25" name="TextBox 24"/>
+          <p:cNvSpPr txBox="1"/>
+          <p:nvPr/>
+        </p:nvSpPr>
+        <p:spPr>
+          <a:xfrm>
+            <a:off x="7086600" y="5239512"/>
+            <a:ext cx="4297680" cy="274320"/>
+          </a:xfrm>
+          <a:prstGeom prst="rect">
+            <a:avLst/>
+          </a:prstGeom>
+          <a:noFill/>
+        </p:spPr>
+        <p:txBody>
+          <a:bodyPr wrap="none">
+            <a:spAutoFit/>
+          </a:bodyPr>
+          <a:lstStyle/>
+          <a:p>
+            <a:r>
+              <a:rPr sz="1150">
                 <a:solidFill>
                   <a:srgbClr val="1565C0"/>
                 </a:solidFill>
                 <a:latin typeface="Calibri"/>
-                <a:hlinkClick r:id="rId15"/>
-              </a:rPr>
-              <a:t>observatoire-dpe-audit.ademe.fr</a:t>
-            </a:r>
-          </a:p>
-          <a:p>
-            <a:pPr>
-              <a:lnSpc>
-                <a:spcPct val="100000"/>
-              </a:lnSpc>
-              <a:spcAft>
-                <a:spcPts val="600"/>
-              </a:spcAft>
-            </a:pPr>
-            <a:r>
-              <a:rPr sz="1100" b="1">
-                <a:solidFill>
-                  <a:srgbClr val="37474F"/>
-                </a:solidFill>
-                <a:latin typeface="Calibri"/>
-              </a:rPr>
-              <a:t>Reglementation (CCH, arretes DPE) </a:t>
-            </a:r>
-          </a:p>
-          <a:p>
-            <a:pPr>
-              <a:lnSpc>
-                <a:spcPct val="100000"/>
-              </a:lnSpc>
-              <a:spcAft>
-                <a:spcPts val="600"/>
-              </a:spcAft>
-            </a:pPr>
-            <a:r>
-              <a:rPr sz="1050">
-                <a:solidFill>
-                  <a:srgbClr val="1565C0"/>
-                </a:solidFill>
-                <a:latin typeface="Calibri"/>
-                <a:hlinkClick r:id="rId16"/>
-              </a:rPr>
-              <a:t>legifrance.gouv.fr</a:t>
-            </a:r>
-          </a:p>
-          <a:p>
-            <a:pPr>
-              <a:lnSpc>
-                <a:spcPct val="100000"/>
-              </a:lnSpc>
-              <a:spcAft>
-                <a:spcPts val="600"/>
-              </a:spcAft>
-            </a:pPr>
-            <a:r>
-              <a:rPr sz="1100" b="1">
-                <a:solidFill>
-                  <a:srgbClr val="37474F"/>
-                </a:solidFill>
-                <a:latin typeface="Calibri"/>
-              </a:rPr>
-              <a:t>Urbanisme / PLU (declaration prealable) </a:t>
-            </a:r>
-          </a:p>
-          <a:p>
-            <a:pPr>
-              <a:lnSpc>
-                <a:spcPct val="100000"/>
-              </a:lnSpc>
-              <a:spcAft>
-                <a:spcPts val="600"/>
-              </a:spcAft>
-            </a:pPr>
-            <a:r>
-              <a:rPr sz="1050">
-                <a:solidFill>
-                  <a:srgbClr val="1565C0"/>
-                </a:solidFill>
-                <a:latin typeface="Calibri"/>
-                <a:hlinkClick r:id="rId17"/>
-              </a:rPr>
-              <a:t>geoportail-urbanisme.gouv.fr</a:t>
-            </a:r>
-          </a:p>
-          <a:p>
-            <a:pPr>
-              <a:lnSpc>
-                <a:spcPct val="100000"/>
-              </a:lnSpc>
-              <a:spcAft>
-                <a:spcPts val="600"/>
-              </a:spcAft>
-            </a:pPr>
-            <a:r>
-              <a:rPr sz="1100" b="1">
-                <a:solidFill>
-                  <a:srgbClr val="37474F"/>
-                </a:solidFill>
-                <a:latin typeface="Calibri"/>
-              </a:rPr>
-              <a:t>Prix de l'energie (statistiques) </a:t>
-            </a:r>
-          </a:p>
-          <a:p>
-            <a:pPr>
-              <a:lnSpc>
-                <a:spcPct val="100000"/>
-              </a:lnSpc>
-              <a:spcAft>
-                <a:spcPts val="600"/>
-              </a:spcAft>
-            </a:pPr>
-            <a:r>
-              <a:rPr sz="1050">
-                <a:solidFill>
-                  <a:srgbClr val="1565C0"/>
-                </a:solidFill>
-                <a:latin typeface="Calibri"/>
-                <a:hlinkClick r:id="rId18"/>
-              </a:rPr>
-              <a:t>statistiques.developpement-durable.gouv.fr</a:t>
-            </a:r>
-          </a:p>
-          <a:p>
-            <a:pPr>
-              <a:lnSpc>
-                <a:spcPct val="100000"/>
-              </a:lnSpc>
-              <a:spcAft>
-                <a:spcPts val="600"/>
-              </a:spcAft>
-            </a:pPr>
-            <a:r>
-              <a:rPr sz="1100" b="1">
-                <a:solidFill>
-                  <a:srgbClr val="37474F"/>
-                </a:solidFill>
-                <a:latin typeface="Calibri"/>
-              </a:rPr>
-              <a:t>Donnees climatiques (DJU, zone H1) </a:t>
-            </a:r>
-          </a:p>
-          <a:p>
-            <a:pPr>
-              <a:lnSpc>
-                <a:spcPct val="100000"/>
-              </a:lnSpc>
-              <a:spcAft>
-                <a:spcPts val="600"/>
-              </a:spcAft>
-            </a:pPr>
-            <a:r>
-              <a:rPr sz="1050">
-                <a:solidFill>
-                  <a:srgbClr val="1565C0"/>
-                </a:solidFill>
-                <a:latin typeface="Calibri"/>
-                <a:hlinkClick r:id="rId19"/>
-              </a:rPr>
-              <a:t>meteofrance.com</a:t>
+                <a:hlinkClick r:id="rId6"/>
+              </a:rPr>
+              <a:t>ademe.fr</a:t>
             </a:r>
           </a:p>
         </p:txBody>

</xml_diff>

<commit_message>
Corrige l'affichage des sous-titres (filet qui les masquait)
Reorganise le bandeau d'en-tete : titre -> sous-titre -> filet bien etages,
sous-titre assombri pour la lisibilite.

https://claude.ai/code/session_01R4E5satKyZK8NHDSVCDJDk
</commit_message>
<xml_diff>
--- a/Soutenance_Renovation_Saint-Jean-de-Chevelu.pptx
+++ b/Soutenance_Renovation_Saint-Jean-de-Chevelu.pptx
@@ -6290,8 +6290,8 @@
         </p:nvSpPr>
         <p:spPr>
           <a:xfrm>
-            <a:off x="1325880" y="365760"/>
-            <a:ext cx="10332720" cy="731520"/>
+            <a:off x="1325880" y="310896"/>
+            <a:ext cx="10332720" cy="566928"/>
           </a:xfrm>
           <a:prstGeom prst="rect">
             <a:avLst/>
@@ -6332,8 +6332,8 @@
         </p:nvSpPr>
         <p:spPr>
           <a:xfrm>
-            <a:off x="1325880" y="1042415"/>
-            <a:ext cx="10332720" cy="365760"/>
+            <a:off x="1325880" y="905256"/>
+            <a:ext cx="10332720" cy="292608"/>
           </a:xfrm>
           <a:prstGeom prst="rect">
             <a:avLst/>
@@ -6355,9 +6355,9 @@
               </a:spcAft>
             </a:pPr>
             <a:r>
-              <a:rPr sz="1400" b="0" i="1">
-                <a:solidFill>
-                  <a:srgbClr val="90A4AE"/>
+              <a:rPr sz="1350" b="0" i="1">
+                <a:solidFill>
+                  <a:srgbClr val="37474F"/>
                 </a:solidFill>
                 <a:latin typeface="Calibri"/>
               </a:rPr>
@@ -6374,7 +6374,7 @@
         </p:nvSpPr>
         <p:spPr>
           <a:xfrm>
-            <a:off x="1325880" y="1152144"/>
+            <a:off x="1325880" y="1225296"/>
             <a:ext cx="10058400" cy="27940"/>
           </a:xfrm>
           <a:prstGeom prst="rect">
@@ -7466,8 +7466,8 @@
         </p:nvSpPr>
         <p:spPr>
           <a:xfrm>
-            <a:off x="1325880" y="365760"/>
-            <a:ext cx="10332720" cy="731520"/>
+            <a:off x="1325880" y="310896"/>
+            <a:ext cx="10332720" cy="566928"/>
           </a:xfrm>
           <a:prstGeom prst="rect">
             <a:avLst/>
@@ -7508,7 +7508,7 @@
         </p:nvSpPr>
         <p:spPr>
           <a:xfrm>
-            <a:off x="1325880" y="1152144"/>
+            <a:off x="1325880" y="1225296"/>
             <a:ext cx="10058400" cy="27940"/>
           </a:xfrm>
           <a:prstGeom prst="rect">
@@ -8626,8 +8626,8 @@
         </p:nvSpPr>
         <p:spPr>
           <a:xfrm>
-            <a:off x="1325880" y="365760"/>
-            <a:ext cx="10332720" cy="731520"/>
+            <a:off x="1325880" y="310896"/>
+            <a:ext cx="10332720" cy="566928"/>
           </a:xfrm>
           <a:prstGeom prst="rect">
             <a:avLst/>
@@ -8668,8 +8668,8 @@
         </p:nvSpPr>
         <p:spPr>
           <a:xfrm>
-            <a:off x="1325880" y="1042415"/>
-            <a:ext cx="10332720" cy="365760"/>
+            <a:off x="1325880" y="905256"/>
+            <a:ext cx="10332720" cy="292608"/>
           </a:xfrm>
           <a:prstGeom prst="rect">
             <a:avLst/>
@@ -8691,9 +8691,9 @@
               </a:spcAft>
             </a:pPr>
             <a:r>
-              <a:rPr sz="1400" b="0" i="1">
-                <a:solidFill>
-                  <a:srgbClr val="90A4AE"/>
+              <a:rPr sz="1350" b="0" i="1">
+                <a:solidFill>
+                  <a:srgbClr val="37474F"/>
                 </a:solidFill>
                 <a:latin typeface="Calibri"/>
               </a:rPr>
@@ -8710,7 +8710,7 @@
         </p:nvSpPr>
         <p:spPr>
           <a:xfrm>
-            <a:off x="1325880" y="1152144"/>
+            <a:off x="1325880" y="1225296"/>
             <a:ext cx="10058400" cy="27940"/>
           </a:xfrm>
           <a:prstGeom prst="rect">
@@ -10885,8 +10885,8 @@
         </p:nvSpPr>
         <p:spPr>
           <a:xfrm>
-            <a:off x="1325880" y="365760"/>
-            <a:ext cx="10332720" cy="731520"/>
+            <a:off x="1325880" y="310896"/>
+            <a:ext cx="10332720" cy="566928"/>
           </a:xfrm>
           <a:prstGeom prst="rect">
             <a:avLst/>
@@ -10927,8 +10927,8 @@
         </p:nvSpPr>
         <p:spPr>
           <a:xfrm>
-            <a:off x="1325880" y="1042415"/>
-            <a:ext cx="10332720" cy="365760"/>
+            <a:off x="1325880" y="905256"/>
+            <a:ext cx="10332720" cy="292608"/>
           </a:xfrm>
           <a:prstGeom prst="rect">
             <a:avLst/>
@@ -10950,9 +10950,9 @@
               </a:spcAft>
             </a:pPr>
             <a:r>
-              <a:rPr sz="1400" b="0" i="1">
-                <a:solidFill>
-                  <a:srgbClr val="90A4AE"/>
+              <a:rPr sz="1350" b="0" i="1">
+                <a:solidFill>
+                  <a:srgbClr val="37474F"/>
                 </a:solidFill>
                 <a:latin typeface="Calibri"/>
               </a:rPr>
@@ -10969,7 +10969,7 @@
         </p:nvSpPr>
         <p:spPr>
           <a:xfrm>
-            <a:off x="1325880" y="1152144"/>
+            <a:off x="1325880" y="1225296"/>
             <a:ext cx="10058400" cy="27940"/>
           </a:xfrm>
           <a:prstGeom prst="rect">
@@ -13453,8 +13453,8 @@
         </p:nvSpPr>
         <p:spPr>
           <a:xfrm>
-            <a:off x="1325880" y="365760"/>
-            <a:ext cx="10332720" cy="731520"/>
+            <a:off x="1325880" y="310896"/>
+            <a:ext cx="10332720" cy="566928"/>
           </a:xfrm>
           <a:prstGeom prst="rect">
             <a:avLst/>
@@ -13495,8 +13495,8 @@
         </p:nvSpPr>
         <p:spPr>
           <a:xfrm>
-            <a:off x="1325880" y="1042415"/>
-            <a:ext cx="10332720" cy="365760"/>
+            <a:off x="1325880" y="905256"/>
+            <a:ext cx="10332720" cy="292608"/>
           </a:xfrm>
           <a:prstGeom prst="rect">
             <a:avLst/>
@@ -13518,9 +13518,9 @@
               </a:spcAft>
             </a:pPr>
             <a:r>
-              <a:rPr sz="1400" b="0" i="1">
-                <a:solidFill>
-                  <a:srgbClr val="90A4AE"/>
+              <a:rPr sz="1350" b="0" i="1">
+                <a:solidFill>
+                  <a:srgbClr val="37474F"/>
                 </a:solidFill>
                 <a:latin typeface="Calibri"/>
               </a:rPr>
@@ -13537,7 +13537,7 @@
         </p:nvSpPr>
         <p:spPr>
           <a:xfrm>
-            <a:off x="1325880" y="1152144"/>
+            <a:off x="1325880" y="1225296"/>
             <a:ext cx="10058400" cy="27940"/>
           </a:xfrm>
           <a:prstGeom prst="rect">
@@ -15936,8 +15936,8 @@
         </p:nvSpPr>
         <p:spPr>
           <a:xfrm>
-            <a:off x="1325880" y="365760"/>
-            <a:ext cx="10332720" cy="731520"/>
+            <a:off x="1325880" y="310896"/>
+            <a:ext cx="10332720" cy="566928"/>
           </a:xfrm>
           <a:prstGeom prst="rect">
             <a:avLst/>
@@ -15978,8 +15978,8 @@
         </p:nvSpPr>
         <p:spPr>
           <a:xfrm>
-            <a:off x="1325880" y="1042415"/>
-            <a:ext cx="10332720" cy="365760"/>
+            <a:off x="1325880" y="905256"/>
+            <a:ext cx="10332720" cy="292608"/>
           </a:xfrm>
           <a:prstGeom prst="rect">
             <a:avLst/>
@@ -16001,9 +16001,9 @@
               </a:spcAft>
             </a:pPr>
             <a:r>
-              <a:rPr sz="1400" b="0" i="1">
-                <a:solidFill>
-                  <a:srgbClr val="90A4AE"/>
+              <a:rPr sz="1350" b="0" i="1">
+                <a:solidFill>
+                  <a:srgbClr val="37474F"/>
                 </a:solidFill>
                 <a:latin typeface="Calibri"/>
               </a:rPr>
@@ -16020,7 +16020,7 @@
         </p:nvSpPr>
         <p:spPr>
           <a:xfrm>
-            <a:off x="1325880" y="1152144"/>
+            <a:off x="1325880" y="1225296"/>
             <a:ext cx="10058400" cy="27940"/>
           </a:xfrm>
           <a:prstGeom prst="rect">
@@ -16946,8 +16946,8 @@
         </p:nvSpPr>
         <p:spPr>
           <a:xfrm>
-            <a:off x="1325880" y="365760"/>
-            <a:ext cx="10332720" cy="731520"/>
+            <a:off x="1325880" y="310896"/>
+            <a:ext cx="10332720" cy="566928"/>
           </a:xfrm>
           <a:prstGeom prst="rect">
             <a:avLst/>
@@ -16988,8 +16988,8 @@
         </p:nvSpPr>
         <p:spPr>
           <a:xfrm>
-            <a:off x="1325880" y="1042415"/>
-            <a:ext cx="10332720" cy="365760"/>
+            <a:off x="1325880" y="905256"/>
+            <a:ext cx="10332720" cy="292608"/>
           </a:xfrm>
           <a:prstGeom prst="rect">
             <a:avLst/>
@@ -17011,9 +17011,9 @@
               </a:spcAft>
             </a:pPr>
             <a:r>
-              <a:rPr sz="1400" b="0" i="1">
-                <a:solidFill>
-                  <a:srgbClr val="90A4AE"/>
+              <a:rPr sz="1350" b="0" i="1">
+                <a:solidFill>
+                  <a:srgbClr val="37474F"/>
                 </a:solidFill>
                 <a:latin typeface="Calibri"/>
               </a:rPr>
@@ -17030,7 +17030,7 @@
         </p:nvSpPr>
         <p:spPr>
           <a:xfrm>
-            <a:off x="1325880" y="1152144"/>
+            <a:off x="1325880" y="1225296"/>
             <a:ext cx="10058400" cy="27940"/>
           </a:xfrm>
           <a:prstGeom prst="rect">
@@ -18890,8 +18890,8 @@
         </p:nvSpPr>
         <p:spPr>
           <a:xfrm>
-            <a:off x="1325880" y="365760"/>
-            <a:ext cx="10332720" cy="731520"/>
+            <a:off x="1325880" y="310896"/>
+            <a:ext cx="10332720" cy="566928"/>
           </a:xfrm>
           <a:prstGeom prst="rect">
             <a:avLst/>
@@ -18932,8 +18932,8 @@
         </p:nvSpPr>
         <p:spPr>
           <a:xfrm>
-            <a:off x="1325880" y="1042415"/>
-            <a:ext cx="10332720" cy="365760"/>
+            <a:off x="1325880" y="905256"/>
+            <a:ext cx="10332720" cy="292608"/>
           </a:xfrm>
           <a:prstGeom prst="rect">
             <a:avLst/>
@@ -18955,9 +18955,9 @@
               </a:spcAft>
             </a:pPr>
             <a:r>
-              <a:rPr sz="1400" b="0" i="1">
-                <a:solidFill>
-                  <a:srgbClr val="90A4AE"/>
+              <a:rPr sz="1350" b="0" i="1">
+                <a:solidFill>
+                  <a:srgbClr val="37474F"/>
                 </a:solidFill>
                 <a:latin typeface="Calibri"/>
               </a:rPr>
@@ -18974,7 +18974,7 @@
         </p:nvSpPr>
         <p:spPr>
           <a:xfrm>
-            <a:off x="1325880" y="1152144"/>
+            <a:off x="1325880" y="1225296"/>
             <a:ext cx="10058400" cy="27940"/>
           </a:xfrm>
           <a:prstGeom prst="rect">
@@ -20136,8 +20136,8 @@
         </p:nvSpPr>
         <p:spPr>
           <a:xfrm>
-            <a:off x="1325880" y="365760"/>
-            <a:ext cx="10332720" cy="731520"/>
+            <a:off x="1325880" y="310896"/>
+            <a:ext cx="10332720" cy="566928"/>
           </a:xfrm>
           <a:prstGeom prst="rect">
             <a:avLst/>
@@ -20178,8 +20178,8 @@
         </p:nvSpPr>
         <p:spPr>
           <a:xfrm>
-            <a:off x="1325880" y="1042415"/>
-            <a:ext cx="10332720" cy="365760"/>
+            <a:off x="1325880" y="905256"/>
+            <a:ext cx="10332720" cy="292608"/>
           </a:xfrm>
           <a:prstGeom prst="rect">
             <a:avLst/>
@@ -20201,9 +20201,9 @@
               </a:spcAft>
             </a:pPr>
             <a:r>
-              <a:rPr sz="1400" b="0" i="1">
-                <a:solidFill>
-                  <a:srgbClr val="90A4AE"/>
+              <a:rPr sz="1350" b="0" i="1">
+                <a:solidFill>
+                  <a:srgbClr val="37474F"/>
                 </a:solidFill>
                 <a:latin typeface="Calibri"/>
               </a:rPr>
@@ -20220,7 +20220,7 @@
         </p:nvSpPr>
         <p:spPr>
           <a:xfrm>
-            <a:off x="1325880" y="1152144"/>
+            <a:off x="1325880" y="1225296"/>
             <a:ext cx="10058400" cy="27940"/>
           </a:xfrm>
           <a:prstGeom prst="rect">
@@ -21386,8 +21386,8 @@
         </p:nvSpPr>
         <p:spPr>
           <a:xfrm>
-            <a:off x="1325880" y="365760"/>
-            <a:ext cx="10332720" cy="731520"/>
+            <a:off x="1325880" y="310896"/>
+            <a:ext cx="10332720" cy="566928"/>
           </a:xfrm>
           <a:prstGeom prst="rect">
             <a:avLst/>
@@ -21428,8 +21428,8 @@
         </p:nvSpPr>
         <p:spPr>
           <a:xfrm>
-            <a:off x="1325880" y="1042415"/>
-            <a:ext cx="10332720" cy="365760"/>
+            <a:off x="1325880" y="905256"/>
+            <a:ext cx="10332720" cy="292608"/>
           </a:xfrm>
           <a:prstGeom prst="rect">
             <a:avLst/>
@@ -21451,9 +21451,9 @@
               </a:spcAft>
             </a:pPr>
             <a:r>
-              <a:rPr sz="1400" b="0" i="1">
-                <a:solidFill>
-                  <a:srgbClr val="90A4AE"/>
+              <a:rPr sz="1350" b="0" i="1">
+                <a:solidFill>
+                  <a:srgbClr val="37474F"/>
                 </a:solidFill>
                 <a:latin typeface="Calibri"/>
               </a:rPr>
@@ -21470,7 +21470,7 @@
         </p:nvSpPr>
         <p:spPr>
           <a:xfrm>
-            <a:off x="1325880" y="1152144"/>
+            <a:off x="1325880" y="1225296"/>
             <a:ext cx="10058400" cy="27940"/>
           </a:xfrm>
           <a:prstGeom prst="rect">
@@ -22385,8 +22385,8 @@
         </p:nvSpPr>
         <p:spPr>
           <a:xfrm>
-            <a:off x="548640" y="365760"/>
-            <a:ext cx="10332720" cy="731520"/>
+            <a:off x="548640" y="310896"/>
+            <a:ext cx="10332720" cy="566928"/>
           </a:xfrm>
           <a:prstGeom prst="rect">
             <a:avLst/>
@@ -22427,7 +22427,7 @@
         </p:nvSpPr>
         <p:spPr>
           <a:xfrm>
-            <a:off x="548640" y="1152144"/>
+            <a:off x="548640" y="1225296"/>
             <a:ext cx="10058400" cy="27940"/>
           </a:xfrm>
           <a:prstGeom prst="rect">
@@ -23937,8 +23937,8 @@
         </p:nvSpPr>
         <p:spPr>
           <a:xfrm>
-            <a:off x="1325880" y="365760"/>
-            <a:ext cx="10332720" cy="731520"/>
+            <a:off x="1325880" y="310896"/>
+            <a:ext cx="10332720" cy="566928"/>
           </a:xfrm>
           <a:prstGeom prst="rect">
             <a:avLst/>
@@ -23979,7 +23979,7 @@
         </p:nvSpPr>
         <p:spPr>
           <a:xfrm>
-            <a:off x="1325880" y="1152144"/>
+            <a:off x="1325880" y="1225296"/>
             <a:ext cx="10058400" cy="27940"/>
           </a:xfrm>
           <a:prstGeom prst="rect">
@@ -24981,8 +24981,8 @@
         </p:nvSpPr>
         <p:spPr>
           <a:xfrm>
-            <a:off x="1325880" y="365760"/>
-            <a:ext cx="10332720" cy="731520"/>
+            <a:off x="1325880" y="310896"/>
+            <a:ext cx="10332720" cy="566928"/>
           </a:xfrm>
           <a:prstGeom prst="rect">
             <a:avLst/>
@@ -25023,7 +25023,7 @@
         </p:nvSpPr>
         <p:spPr>
           <a:xfrm>
-            <a:off x="1325880" y="1152144"/>
+            <a:off x="1325880" y="1225296"/>
             <a:ext cx="10058400" cy="27940"/>
           </a:xfrm>
           <a:prstGeom prst="rect">
@@ -26972,8 +26972,8 @@
         </p:nvSpPr>
         <p:spPr>
           <a:xfrm>
-            <a:off x="548640" y="365760"/>
-            <a:ext cx="10332720" cy="731520"/>
+            <a:off x="548640" y="310896"/>
+            <a:ext cx="10332720" cy="566928"/>
           </a:xfrm>
           <a:prstGeom prst="rect">
             <a:avLst/>
@@ -27014,8 +27014,8 @@
         </p:nvSpPr>
         <p:spPr>
           <a:xfrm>
-            <a:off x="548640" y="1042415"/>
-            <a:ext cx="10332720" cy="365760"/>
+            <a:off x="548640" y="905256"/>
+            <a:ext cx="10332720" cy="292608"/>
           </a:xfrm>
           <a:prstGeom prst="rect">
             <a:avLst/>
@@ -27037,9 +27037,9 @@
               </a:spcAft>
             </a:pPr>
             <a:r>
-              <a:rPr sz="1400" b="0" i="1">
-                <a:solidFill>
-                  <a:srgbClr val="90A4AE"/>
+              <a:rPr sz="1350" b="0" i="1">
+                <a:solidFill>
+                  <a:srgbClr val="37474F"/>
                 </a:solidFill>
                 <a:latin typeface="Calibri"/>
               </a:rPr>
@@ -27056,7 +27056,7 @@
         </p:nvSpPr>
         <p:spPr>
           <a:xfrm>
-            <a:off x="548640" y="1152144"/>
+            <a:off x="548640" y="1225296"/>
             <a:ext cx="10058400" cy="27940"/>
           </a:xfrm>
           <a:prstGeom prst="rect">
@@ -28231,8 +28231,8 @@
         </p:nvSpPr>
         <p:spPr>
           <a:xfrm>
-            <a:off x="1325880" y="365760"/>
-            <a:ext cx="10332720" cy="731520"/>
+            <a:off x="1325880" y="310896"/>
+            <a:ext cx="10332720" cy="566928"/>
           </a:xfrm>
           <a:prstGeom prst="rect">
             <a:avLst/>
@@ -28273,8 +28273,8 @@
         </p:nvSpPr>
         <p:spPr>
           <a:xfrm>
-            <a:off x="1325880" y="1042415"/>
-            <a:ext cx="10332720" cy="365760"/>
+            <a:off x="1325880" y="905256"/>
+            <a:ext cx="10332720" cy="292608"/>
           </a:xfrm>
           <a:prstGeom prst="rect">
             <a:avLst/>
@@ -28296,9 +28296,9 @@
               </a:spcAft>
             </a:pPr>
             <a:r>
-              <a:rPr sz="1400" b="0" i="1">
-                <a:solidFill>
-                  <a:srgbClr val="90A4AE"/>
+              <a:rPr sz="1350" b="0" i="1">
+                <a:solidFill>
+                  <a:srgbClr val="37474F"/>
                 </a:solidFill>
                 <a:latin typeface="Calibri"/>
               </a:rPr>
@@ -28315,7 +28315,7 @@
         </p:nvSpPr>
         <p:spPr>
           <a:xfrm>
-            <a:off x="1325880" y="1152144"/>
+            <a:off x="1325880" y="1225296"/>
             <a:ext cx="10058400" cy="27940"/>
           </a:xfrm>
           <a:prstGeom prst="rect">
@@ -29102,8 +29102,8 @@
         </p:nvSpPr>
         <p:spPr>
           <a:xfrm>
-            <a:off x="1325880" y="365760"/>
-            <a:ext cx="10332720" cy="731520"/>
+            <a:off x="1325880" y="310896"/>
+            <a:ext cx="10332720" cy="566928"/>
           </a:xfrm>
           <a:prstGeom prst="rect">
             <a:avLst/>
@@ -29144,8 +29144,8 @@
         </p:nvSpPr>
         <p:spPr>
           <a:xfrm>
-            <a:off x="1325880" y="1042415"/>
-            <a:ext cx="10332720" cy="365760"/>
+            <a:off x="1325880" y="905256"/>
+            <a:ext cx="10332720" cy="292608"/>
           </a:xfrm>
           <a:prstGeom prst="rect">
             <a:avLst/>
@@ -29167,9 +29167,9 @@
               </a:spcAft>
             </a:pPr>
             <a:r>
-              <a:rPr sz="1400" b="0" i="1">
-                <a:solidFill>
-                  <a:srgbClr val="90A4AE"/>
+              <a:rPr sz="1350" b="0" i="1">
+                <a:solidFill>
+                  <a:srgbClr val="37474F"/>
                 </a:solidFill>
                 <a:latin typeface="Calibri"/>
               </a:rPr>
@@ -29186,7 +29186,7 @@
         </p:nvSpPr>
         <p:spPr>
           <a:xfrm>
-            <a:off x="1325880" y="1152144"/>
+            <a:off x="1325880" y="1225296"/>
             <a:ext cx="10058400" cy="27940"/>
           </a:xfrm>
           <a:prstGeom prst="rect">
@@ -29937,8 +29937,8 @@
         </p:nvSpPr>
         <p:spPr>
           <a:xfrm>
-            <a:off x="1325880" y="365760"/>
-            <a:ext cx="10332720" cy="731520"/>
+            <a:off x="1325880" y="310896"/>
+            <a:ext cx="10332720" cy="566928"/>
           </a:xfrm>
           <a:prstGeom prst="rect">
             <a:avLst/>
@@ -29979,7 +29979,7 @@
         </p:nvSpPr>
         <p:spPr>
           <a:xfrm>
-            <a:off x="1325880" y="1152144"/>
+            <a:off x="1325880" y="1225296"/>
             <a:ext cx="10058400" cy="27940"/>
           </a:xfrm>
           <a:prstGeom prst="rect">
@@ -30809,8 +30809,8 @@
         </p:nvSpPr>
         <p:spPr>
           <a:xfrm>
-            <a:off x="1325880" y="365760"/>
-            <a:ext cx="10332720" cy="731520"/>
+            <a:off x="1325880" y="310896"/>
+            <a:ext cx="10332720" cy="566928"/>
           </a:xfrm>
           <a:prstGeom prst="rect">
             <a:avLst/>
@@ -30851,7 +30851,7 @@
         </p:nvSpPr>
         <p:spPr>
           <a:xfrm>
-            <a:off x="1325880" y="1152144"/>
+            <a:off x="1325880" y="1225296"/>
             <a:ext cx="10058400" cy="27940"/>
           </a:xfrm>
           <a:prstGeom prst="rect">
@@ -31679,8 +31679,8 @@
         </p:nvSpPr>
         <p:spPr>
           <a:xfrm>
-            <a:off x="1325880" y="365760"/>
-            <a:ext cx="10332720" cy="731520"/>
+            <a:off x="1325880" y="310896"/>
+            <a:ext cx="10332720" cy="566928"/>
           </a:xfrm>
           <a:prstGeom prst="rect">
             <a:avLst/>
@@ -31721,7 +31721,7 @@
         </p:nvSpPr>
         <p:spPr>
           <a:xfrm>
-            <a:off x="1325880" y="1152144"/>
+            <a:off x="1325880" y="1225296"/>
             <a:ext cx="10058400" cy="27940"/>
           </a:xfrm>
           <a:prstGeom prst="rect">
@@ -32607,8 +32607,8 @@
         </p:nvSpPr>
         <p:spPr>
           <a:xfrm>
-            <a:off x="1325880" y="365760"/>
-            <a:ext cx="10332720" cy="731520"/>
+            <a:off x="1325880" y="310896"/>
+            <a:ext cx="10332720" cy="566928"/>
           </a:xfrm>
           <a:prstGeom prst="rect">
             <a:avLst/>
@@ -32649,8 +32649,8 @@
         </p:nvSpPr>
         <p:spPr>
           <a:xfrm>
-            <a:off x="1325880" y="1042415"/>
-            <a:ext cx="10332720" cy="365760"/>
+            <a:off x="1325880" y="905256"/>
+            <a:ext cx="10332720" cy="292608"/>
           </a:xfrm>
           <a:prstGeom prst="rect">
             <a:avLst/>
@@ -32672,9 +32672,9 @@
               </a:spcAft>
             </a:pPr>
             <a:r>
-              <a:rPr sz="1400" b="0" i="1">
-                <a:solidFill>
-                  <a:srgbClr val="90A4AE"/>
+              <a:rPr sz="1350" b="0" i="1">
+                <a:solidFill>
+                  <a:srgbClr val="37474F"/>
                 </a:solidFill>
                 <a:latin typeface="Calibri"/>
               </a:rPr>
@@ -32691,7 +32691,7 @@
         </p:nvSpPr>
         <p:spPr>
           <a:xfrm>
-            <a:off x="1325880" y="1152144"/>
+            <a:off x="1325880" y="1225296"/>
             <a:ext cx="10058400" cy="27940"/>
           </a:xfrm>
           <a:prstGeom prst="rect">
@@ -33839,8 +33839,8 @@
         </p:nvSpPr>
         <p:spPr>
           <a:xfrm>
-            <a:off x="1325880" y="365760"/>
-            <a:ext cx="10332720" cy="731520"/>
+            <a:off x="1325880" y="310896"/>
+            <a:ext cx="10332720" cy="566928"/>
           </a:xfrm>
           <a:prstGeom prst="rect">
             <a:avLst/>
@@ -33881,7 +33881,7 @@
         </p:nvSpPr>
         <p:spPr>
           <a:xfrm>
-            <a:off x="1325880" y="1152144"/>
+            <a:off x="1325880" y="1225296"/>
             <a:ext cx="10058400" cy="27940"/>
           </a:xfrm>
           <a:prstGeom prst="rect">

</xml_diff>